<commit_message>
namul: v4.1 — Codex 2차 리뷰 반영
- 근거 표현: 온라인 식품 '40조(2024)' 숫자 삭제(연도 오기), 편식 연구는
  '대구 지역 유아 86명 조사에서 반찬류 비선호'로 좁히고 정식 서지 표기,
  판매자 문제는 인터뷰로 확인할 가설로 표시, '예약까지 약 1분' 삭제,
  '최대 8.0억'은 확장 시나리오(미검증)로
- 문구: O2O를 한 번 풀어 말하고, 리뷰가 제안한 자연스러운 대본 문장 반영,
  요금은 예정안 표기, 5장 '시연 구현'과 실호출 미검증 각주, 경쟁 맵 축 정리,
  부록 2 출처에 원문 하이퍼링크
- 상세본: 손익표를 기본 시나리오(4.9억·−1.6억) 중심으로, 8억은 확장 시나리오로
  분리, 건당 호출비를 결제 기준 28~38원으로 정리, 04 A5 무관 링크 삭제·A13 추가
- 프로토타입: 만 단위 금액, 음수·긴 숫자, '안 됩니다' 부정, g·kg 단위 확인,
  품목 재선택, 엄격한 숫자 타입, 품목별 손질 여부를 AI 프롬프트에 반영
  (check2.js 반례 추가)
- 대본 추정 8:30, AI 음성 초안 8:35, npm lockfile과 Python 버전 고정

Co-Authored-By: Claude Opus 5.5 <noreply@anthropic.com>
Claude-Session: https://claude.ai/code/session_01WM2pJ2E8tXi8UPjx1jXtrm
</commit_message>
<xml_diff>
--- a/namul-platform/02_발표자료_나물로.pptx
+++ b/namul-platform/02_발표자료_나물로.pptx
@@ -120,43 +120,43 @@
   <p:extLst>
     <p:ext uri="{521415D9-36F7-43E2-AB2F-B90AF26B5E84}">
       <p14:sectionLst xmlns:p14="http://schemas.microsoft.com/office/powerpoint/2010/main">
-        <p14:section name="표지" id="{485a27a5-d14c-0fde-0069-15a9d349d248}">
+        <p14:section name="표지" id="{c924725b-0c95-e479-d338-7f676a489a74}">
           <p14:sldIdLst>
             <p14:sldId id="256"/>
           </p14:sldIdLst>
         </p14:section>
-        <p14:section name="Problem" id="{baeac055-e2dc-f631-b197-fa413f23c70f}">
+        <p14:section name="Problem" id="{2967e55f-1a90-1d3d-32a5-e2fc5053f87f}">
           <p14:sldIdLst>
             <p14:sldId id="257"/>
             <p14:sldId id="258"/>
           </p14:sldIdLst>
         </p14:section>
-        <p14:section name="Solution" id="{c6726ee4-0e2c-f7f5-7287-b2968459a607}">
+        <p14:section name="Solution" id="{fc1665e9-85c3-8dc1-1a04-e3a139e4a094}">
           <p14:sldIdLst>
             <p14:sldId id="259"/>
             <p14:sldId id="260"/>
             <p14:sldId id="261"/>
           </p14:sldIdLst>
         </p14:section>
-        <p14:section name="Business" id="{6224f4f3-c974-5a37-72ef-aa0448d9cb9d}">
+        <p14:section name="Business" id="{661df5cb-083f-052b-e464-199c9f36a2b8}">
           <p14:sldIdLst>
             <p14:sldId id="262"/>
             <p14:sldId id="263"/>
             <p14:sldId id="264"/>
           </p14:sldIdLst>
         </p14:section>
-        <p14:section name="Vision" id="{ad251ed0-c2d2-b67e-0a90-2617a968a0b2}">
+        <p14:section name="Vision" id="{7a13cda0-4cd3-f1e6-6e76-bace6dd45e6f}">
           <p14:sldIdLst>
             <p14:sldId id="265"/>
             <p14:sldId id="266"/>
           </p14:sldIdLst>
         </p14:section>
-        <p14:section name="마무리" id="{36df947b-65be-38f9-9888-19c318505263}">
+        <p14:section name="마무리" id="{c36595ba-753e-083a-88f2-1a9365befbdc}">
           <p14:sldIdLst>
             <p14:sldId id="267"/>
           </p14:sldIdLst>
         </p14:section>
-        <p14:section name="부록" id="{ae6623a2-fc7a-1b5c-f56d-cdbef119c039}">
+        <p14:section name="부록" id="{59e9133b-0423-1f85-3ba1-e48050d97752}">
           <p14:sldIdLst>
             <p14:sldId id="268"/>
             <p14:sldId id="269"/>
@@ -859,7 +859,7 @@
           <a:p>
             <a:r>
               <a:rPr lang="en-US" dirty="0"/>
-              <a:t>[0:00–0:21] 안녕하세요. 오늘 발표할 창업 아이템은 나물로입니다. 나물로는 제철 나물 레시피를 보고, 필요한 재료를 집 근처 전통시장이나 로컬푸드 매장에서 바로 픽업 주문하는 O2O 플랫폼입니다. 문제, 해결 방안, 사업성, 향후 계획 순서로 말씀드리겠습니다.</a:t>
+              <a:t>[0:00–0:24] 안녕하세요. 오늘 발표할 창업 아이템은 나물로입니다. 나물로는 레시피를 고른 뒤 필요한 나물을 동네 가게에 주문하고 찾아갈 수 있는 서비스입니다. 온라인으로 주문하고 가게에서 찾아가는 방식이라, 흔히 O2O 서비스라고 부릅니다. 문제, 해결 방안, 사업성, 향후 계획 순서로 말씀드리겠습니다.</a:t>
             </a:r>
             <a:endParaRPr lang="en-US" dirty="0"/>
           </a:p>
@@ -947,7 +947,7 @@
           <a:p>
             <a:r>
               <a:rPr lang="en-US" dirty="0"/>
-              <a:t>[6:27–7:11] 사업화는 세 단계로 진행합니다. 1단계는 올겨울, 주거 단지 근처 전통시장 한 곳의 점포 두세 곳과 함께하는 3개월 파일럿입니다. 자기자본 300만 원으로 시작합니다. 여기서 유료 주문 100건을 목표로, 30일 재구매율, 손질 옵션 선택률, 주문 한 건당 운영 시간을 측정해 사업성을 검증하겠습니다. 결과가 기대에 못 미치면 타깃 고객이나 가격을 바꿔 다시 검증하겠습니다. 2단계는 예비창업패키지 같은 정부 지원사업으로 웹앱을 정식 출시하고 입점 매장을 30곳으로 늘리는 것이고, 3단계는 시드 투자를 받아 수도권으로 확장하는 것입니다.</a:t>
+              <a:t>[6:47–7:32] 사업화는 세 단계로 진행합니다. 1단계는 올겨울, 주거 단지 근처 전통시장 한 곳의 점포 두세 곳과 함께하는 3개월 파일럿입니다. 자기자본 300만 원으로 시작합니다. 여기서 유료 주문 100건을 목표로, 30일 재구매율, 손질 옵션 선택률, 주문 한 건당 운영 시간을 측정해 사업성을 검증하겠습니다. 결과가 기대에 못 미치면 타깃 고객이나 가격을 바꿔 다시 검증하겠습니다. 2단계는 예비창업패키지 같은 정부 지원사업으로 웹앱을 정식 출시하고 입점 매장을 30곳으로 늘리는 것이고, 3단계는 시드 투자를 받아 수도권으로 확장하는 것입니다.</a:t>
             </a:r>
             <a:endParaRPr lang="en-US" dirty="0"/>
           </a:p>
@@ -1035,7 +1035,7 @@
           <a:p>
             <a:r>
               <a:rPr lang="en-US" dirty="0"/>
-              <a:t>[7:11–7:50] 3년 차 목표는 거래액 54억 원, 매출 약 5억 원입니다. 지자체 전통시장 사업이나 제휴 매출이 더해지면 8억 원까지 볼 수 있지만, 아직 계약 근거가 없어 기본 목표에서는 뺐습니다. 숫자는 모두 가정이라, 파일럿이 끝나면 실제 데이터로 다시 계산하겠습니다. 이후에는 나물에서 제철 농산물 전체로 품목을 넓히고, 산지 직거래와 건조 나물 해외 판매로 확장하려고 합니다. 이를 통해 전통시장의 매출을 늘리고, 아이들이 채소 반찬을 더 쉽게 먹도록 돕는 것이 목표입니다.</a:t>
+              <a:t>[7:32–8:09] 3년 차 목표는 거래액 54억 원, 매출 약 5억 원입니다. 지자체 사업이나 제휴 매출은 아직 계약 근거가 없어 목표에서 뺐고, 계약을 확보하면 그때 더하겠습니다. 숫자는 모두 가정이라, 파일럿이 끝나면 실제 데이터로 다시 계산하겠습니다. 이후에는 나물에서 제철 농산물 전체로 품목을 넓히고, 산지 직거래와 건조 나물 해외 판매로 확장하려고 합니다. 이를 통해 전통시장의 매출을 늘리고, 아이들이 채소 반찬을 더 쉽게 먹도록 돕는 것이 목표입니다.</a:t>
             </a:r>
             <a:endParaRPr lang="en-US" dirty="0"/>
           </a:p>
@@ -1123,7 +1123,7 @@
           <a:p>
             <a:r>
               <a:rPr lang="en-US" dirty="0"/>
-              <a:t>[7:50–8:17] 정리하겠습니다. 나물로는 바쁜 맞벌이 가정에는 레시피와 동네 매장 픽업을, 전통시장 판매자에게는 온라인 판매 채널을 제공하는 플랫폼입니다. 먼저 시장 한 곳에서 파일럿으로 실제 수요를 확인하겠습니다. 나물을 더 쉽게 사고 더 쉽게 먹을 수 있게 만드는 것, 그것이 나물로가 하려는 일입니다. 들어 주셔서 감사합니다.</a:t>
+              <a:t>[8:09–8:30] 정리하겠습니다. 나물로는 바쁜 맞벌이 가정에는 레시피와 동네 매장 픽업을, 전통시장 판매자에게는 온라인 판매 채널을 제공하는 서비스입니다. 먼저 시장 한 곳에서 사람들이 실제로 주문하고 다시 찾아오는지 확인해 보겠습니다. 들어 주셔서 감사합니다.</a:t>
             </a:r>
             <a:endParaRPr lang="en-US" dirty="0"/>
           </a:p>
@@ -1387,7 +1387,7 @@
           <a:p>
             <a:r>
               <a:rPr lang="en-US" dirty="0"/>
-              <a:t>[0:21–1:13] 먼저 고객 쪽 문제입니다. 첫 고객으로는 전통시장 근처에 사는 맞벌이 자녀 가구를 정했습니다. 18세 미만 자녀를 둔 부부 가구 가운데 맞벌이 비율은 작년에 60.4%로, 처음 60%를 넘었습니다. 여섯 시에 퇴근한 부모가 일곱 시 전에 아이 저녁을 차려야 하는 상황을 떠올리시면 됩니다. 장을 보고 요리할 시간이 부족하고, 아이가 채소 반찬을 잘 먹지 않아 메뉴 고르기도 어렵습니다. 나물은 다듬고 데치는 손질이 번거롭고, 마트나 온라인몰은 한 단, 한 봉지 단위라 조금만 사기도 불편합니다. 어린 자녀일수록 반찬 편식이 심하다는 연구도 있어서, 무엇을 어디서 사서 어떻게 해 먹을지를 한 번에 알려 주는 서비스가 필요하다고 봤습니다.</a:t>
+              <a:t>[0:24–1:22] 먼저 고객 쪽 문제입니다. 처음에는 전통시장 근처에 살면서 아이를 키우는 맞벌이 가정을 대상으로 생각했습니다. 18세 미만 자녀를 둔 부부 가구 가운데 맞벌이 비율은 작년에 60.4%로, 처음 60%를 넘었습니다. 여섯 시에 퇴근한 부모가 일곱 시 전에 아이 저녁을 차려야 하는 상황을 떠올리시면 됩니다. 장을 보고 요리할 시간이 부족하고, 아이가 채소 반찬을 잘 먹지 않아 메뉴 고르기도 어렵습니다. 나물은 다듬고 데치는 손질이 번거롭고, 마트나 온라인몰은 한 단, 한 봉지 단위라 조금만 사기도 불편합니다. 대구 지역 유아 86명을 조사한 연구에서도 반찬류를 꺼리는 경향이 나타났습니다. 그래서 무엇을 어디서 사서 어떻게 해 먹을지를 한 번에 알려 주는 서비스가 필요하다고 봤습니다.</a:t>
             </a:r>
             <a:endParaRPr lang="en-US" dirty="0"/>
           </a:p>
@@ -1475,7 +1475,7 @@
           <a:p>
             <a:r>
               <a:rPr lang="en-US" dirty="0"/>
-              <a:t>[1:13–2:01] 다음은 판매자 쪽입니다. 전국 전통시장은 약 1,400곳, 연매출은 28.7조 원 규모입니다. 하지만 상인 대부분은 온라인에 상품을 올리고 재고를 관리할 인력과 시간이 부족합니다. 나물은 손질에 손이 많이 가는 품목이라 손질해서 팔면 더 좋은 가격을 받을 수 있는데, 이런 서비스를 알릴 방법도 마땅치 않습니다. 산나물은 제철에 물량이 몰리는데, 2024년 산나물 생산액은 전년보다 9.3% 줄었습니다. 한편 배민 전통시장 장보기에 입점한 점포의 매출이 1년 사이 196% 늘었다는 보도를 보면, 시장 상품을 온라인으로 사려는 수요는 있다고 판단했습니다.</a:t>
+              <a:t>[1:22–2:13] 다음은 판매자 쪽입니다. 전국 전통시장은 약 1,400곳, 연매출은 28.7조 원 규모입니다. 배민 전통시장 장보기에 입점한 점포의 매출이 1년 사이 196% 늘었다는 보도를 보면, 시장 상품을 온라인으로 사려는 수요는 있다고 판단했습니다. 다만 상인이 상품을 올리고 주문까지 직접 관리하려면 일이 꽤 늘어날 것으로 봤습니다. 손질해서 팔면 값을 더 받을 수 있는데도 이를 알릴 방법이 마땅치 않고, 제철에는 물량이 몰려 재고 부담도 클 것으로 예상합니다. 이 부분은 아직 가설이라서, 시장 상인 인터뷰로 실제 부담을 확인하려고 합니다. 참고로 산나물 생산액은 2024년에 전년보다 9.3% 줄었습니다.</a:t>
             </a:r>
             <a:endParaRPr lang="en-US" dirty="0"/>
           </a:p>
@@ -1563,7 +1563,7 @@
           <a:p>
             <a:r>
               <a:rPr lang="en-US" dirty="0"/>
-              <a:t>[2:01–2:46] 그래서 나물로는 세 단계로 서비스를 제공합니다. 첫째, 제철 나물 정보와 손질법, 레시피를 보여 주고, 아이가 잘 먹는 메뉴를 따로 추천합니다. 둘째, 레시피 재료 가운데 집에 없는 것만 골라 장바구니에 담습니다. 셋째, 반경 3km 안의 전통시장, 로컬푸드 매장, 반찬가게 중 한 곳을 골라 픽업 시간을 예약합니다. 손질이나 데침을 원하면 매장에서 추가 요금을 받고 처리해 주고, 매주 제철 나물을 받는 정기구독 상품도 함께 운영합니다. 고객은 레시피를 보다가 바로 주문까지 할 수 있고, 판매자는 따로 배송하지 않고 매장 픽업으로 판매할 수 있습니다.</a:t>
+              <a:t>[2:13–2:59] 그래서 나물로는 세 단계로 서비스를 제공합니다. 첫째, 제철 나물 정보와 손질법, 레시피를 보여 주고, 아이가 잘 먹는 메뉴를 따로 추천합니다. 둘째, 레시피 재료 가운데 집에 없는 것만 골라 장바구니에 담습니다. 셋째, 반경 3km 안의 전통시장, 로컬푸드 매장, 반찬가게 중 한 곳을 골라 픽업 시간을 예약합니다. 손질이나 데침을 원하면 매장에서 추가 요금을 받고 처리해 주고, 매주 제철 나물을 받는 정기구독 상품도 함께 운영할 계획입니다. 고객은 레시피를 보다가 바로 주문까지 할 수 있고, 판매자는 따로 배송하지 않고 매장 픽업으로 판매할 수 있습니다.</a:t>
             </a:r>
             <a:endParaRPr lang="en-US" dirty="0"/>
           </a:p>
@@ -1651,7 +1651,7 @@
           <a:p>
             <a:r>
               <a:rPr lang="en-US" dirty="0"/>
-              <a:t>[2:46–3:38] AI는 세 가지 업무에 적용합니다. 첫째는 고객용 레시피 추천입니다. 아이 나이나 집에 있는 재료를 입력하면, 근처 매장 재고로 만들 수 있는 반찬을 추천합니다. 둘째는 판매자용 상품 등록입니다. 사장님이 평소처럼 참나물 스무 단, 한 단 3,500원이라고 메시지를 보내면, AI가 품목과 수량, 가격으로 정리하고, 사장님이 확인을 눌러야 앱에 올라갑니다. 셋째는 발주량 추천과 마감 할인인데, 이 기능은 주문 데이터가 쌓인 뒤에 도입할 계획입니다. 앞의 두 기능은 프로토타입에 구현했고, 화면의 매장과 가격, 예측 수치는 예시 데이터입니다. 또 안전을 위해 AI가 야생에서 캔 식물의 식용 여부는 판단하지 않도록 했습니다.</a:t>
+              <a:t>[2:59–3:51] AI는 세 가지 업무에 적용하려고 합니다. 첫째는 고객용 레시피 추천입니다. 아이 나이나 집에 있는 재료를 입력하면, 근처 매장 재고로 만들 수 있는 반찬을 추천합니다. 둘째는 판매자용 상품 등록입니다. 사장님이 평소처럼 참나물 스무 단, 한 단 3,500원이라고 메시지를 보내면, AI가 품목과 수량, 가격으로 정리하고, 사장님이 확인을 눌러야 앱에 올라갑니다. 셋째는 발주량 추천과 마감 할인인데, 이 기능은 주문 데이터가 쌓인 뒤에 도입할 계획입니다. 앞의 두 기능은 시연 화면까지 만들어 두었고, 화면의 응답과 매장, 가격은 예시 데이터입니다. 또 안전을 위해 AI가 야생에서 캔 식물의 식용 여부는 판단하지 않도록 했습니다.</a:t>
             </a:r>
             <a:endParaRPr lang="en-US" dirty="0"/>
           </a:p>
@@ -1739,7 +1739,7 @@
           <a:p>
             <a:r>
               <a:rPr lang="en-US" dirty="0"/>
-              <a:t>[3:38–4:16] 웹 프로토타입으로 실제 사용 흐름을 보여 드리겠습니다. 맞벌이 부모가 다섯 살 아이와 먹을 순한 반찬을 물으면, 추천 메뉴 세 가지가 나옵니다. 참나물 레시피를 보고 재료를 담은 뒤, 600미터 떨어진 시장 가게에서 손질 옵션과 저녁 6시 픽업을 고릅니다. 판매자 화면에서는 들어온 주문을 확인하고 접수합니다. 메뉴를 고르고 예약하기까지 1분 정도 걸립니다. 시연 속 AI 응답과 주문 데이터는 예시이고, 실제 결제와 알림 연동은 파일럿에서 검증하겠습니다.</a:t>
+              <a:t>[3:51–4:32] 웹 프로토타입으로 사용 흐름을 보여 드리겠습니다. 맞벌이 부모가 다섯 살 아이와 먹을 순한 반찬을 물으면, 추천 메뉴 세 가지가 나옵니다. 참나물 레시피를 보고 재료를 담은 뒤, 600미터 떨어진 시장 가게에서 손질 옵션과 저녁 6시 픽업을 고릅니다. 판매자 화면에서는 들어온 주문을 확인하고 접수합니다. 추천 확인부터 예약, 판매자 접수까지가 한 흐름으로 이어지도록 만들었습니다. 시연 속 AI 응답과 주문 데이터는 예시이고, 실제 결제와 알림 연동은 파일럿에서 검증하겠습니다.</a:t>
             </a:r>
             <a:endParaRPr lang="en-US" dirty="0"/>
           </a:p>
@@ -1827,7 +1827,7 @@
           <a:p>
             <a:r>
               <a:rPr lang="en-US" dirty="0"/>
-              <a:t>[4:16–4:57] 다음은 시장 규모입니다. 전통시장 전체 매출 28.7조 원에서 수도권 비중 40%와 채소, 나물류 비중 15%를 가정해, 1차 목표 시장을 약 1.7조 원으로 잡았습니다. 온라인 식품 시장까지 더하면 숫자는 커지지만, 전통시장 매출과 겹치는 부분이 있어 이번에는 합치지 않았습니다. 또 이 비율은 가정치라서 파일럿의 실제 판매 데이터로 다시 확인하겠습니다. 3년 차 목표 거래액은 입점 매장 300곳이 한 달에 100건씩, 평균 1만 5천 원 주문을 받는다고 보고 54억 원으로 정했습니다.</a:t>
+              <a:t>[4:32–5:14] 다음은 시장 규모입니다. 전통시장 전체 매출 28.7조 원에서 수도권 비중 40%와 채소, 나물류 비중 15%를 가정해, 1차 목표 시장을 약 1.7조 원으로 잡았습니다. 온라인 식품 거래와는 겹치는 부분이 있어서, 전통시장 매출만 기준으로 삼았습니다. 수도권과 품목 비중은 공개 통계로 보완하고, 파일럿에서는 참여 점포의 나물 매출과 주문 가능성을 확인하겠습니다. 3년 차 목표 거래액은 입점 매장 300곳이 한 달에 100건씩, 평균 1만 5천 원 주문을 받는다고 가정해 54억 원으로 정했습니다.</a:t>
             </a:r>
             <a:endParaRPr lang="en-US" dirty="0"/>
           </a:p>
@@ -1915,7 +1915,7 @@
           <a:p>
             <a:r>
               <a:rPr lang="en-US" dirty="0"/>
-              <a:t>[4:57–5:42] 경쟁 서비스를 보면, 쿠팡과 컬리는 전국 배송, 레시피 앱과 유튜브는 콘텐츠에 강하고, 배민과 네이버는 동네 가게 주문과 판매자 도구를 갖추고 있습니다. 나물로는 그중에서도 나물 레시피, 동네 매장 재고, 손질 옵션, 픽업 주문을 한 번의 구매 과정으로 묶는 데 집중합니다. 특히 손질과 데침 옵션은 판매자에게는 추가 매출이 되고, 고객에게는 조리 시간을 줄여 줍니다. 또 앱이 익숙하지 않은 상인도 메시지 한 줄로 상품을 올릴 수 있게 했습니다. 큰 플랫폼과 정면으로 경쟁하기보다, 상인들이 함께 쓸 수 있는 나물 전문 판매 채널로 자리 잡는 것이 목표입니다.</a:t>
+              <a:t>[5:14–5:58] 경쟁 서비스를 보면, 쿠팡과 컬리는 전국 배송, 레시피 앱과 유튜브는 콘텐츠에 강하고, 배민과 네이버는 동네 가게 주문과 판매자 도구를 갖추고 있습니다. 나물로는 나물 요리를 고른 사람이 필요한 재료를 동네에서 손질까지 받아 살 수 있도록 만드는 데 집중했습니다. 손질과 데침 옵션은 판매자에게는 추가 매출이 되고, 고객에게는 조리 시간을 줄여 줍니다. 또 앱이 익숙하지 않은 상인도 메시지 한 줄로 상품을 올릴 수 있게 했습니다. 큰 플랫폼과 정면으로 경쟁하기보다, 상인들이 함께 쓸 수 있는 나물 전문 판매 채널로 자리 잡는 것이 목표입니다.</a:t>
             </a:r>
             <a:endParaRPr lang="en-US" dirty="0"/>
           </a:p>
@@ -2003,7 +2003,7 @@
           <a:p>
             <a:r>
               <a:rPr lang="en-US" dirty="0"/>
-              <a:t>[5:42–6:27] 수익 모델은 네 가지입니다. 기본은 주문 금액의 4% 중개 수수료와, 월 29,900원에서 39,900원인 정기구독입니다. 정기구독은 매주 정해진 요일에 매장에서 픽업하는 방식이라, 판매자도 물량을 미리 준비할 수 있습니다. 여기에 판매자가 선택하는 월 2만 9천 원의 유료 서비스와, 레시피 크리에이터 제휴 광고를 더합니다. 판매자 부담을 계산해 보면, 한 달에 100건을 파는 매장은 수수료와 유료 서비스를 합쳐 거래액의 약 6%를 냅니다. 입점을 늘리기 위해 전통시장 점포는 첫 6개월 동안 수수료를 받지 않겠습니다.</a:t>
+              <a:t>[5:58–6:47] 수익 모델은 네 가지입니다. 요금은 모두 예정안이고, 파일럿에서 검증할 계획입니다. 기본은 주문 금액의 4% 중개 수수료와, 월 29,900원에서 39,900원인 정기구독입니다. 정기구독은 매주 정해진 요일에 매장에서 픽업하는 방식이라, 판매자도 물량을 미리 준비할 수 있습니다. 여기에 판매자가 선택하는 월 2만 9천 원의 유료 서비스와, 레시피 크리에이터 제휴 광고를 더합니다. 판매자 부담을 계산해 보면, 한 달에 100건을 파는 매장은 수수료와 유료 서비스를 합쳐 거래액의 약 6%를 냅니다. 입점을 늘리기 위해 전통시장 점포는 첫 6개월 동안 수수료를 받지 않겠습니다.</a:t>
             </a:r>
             <a:endParaRPr lang="en-US" dirty="0"/>
           </a:p>
@@ -4867,7 +4867,7 @@
                   <a:srgbClr val="1F2421"/>
                 </a:solidFill>
               </a:rPr>
-              <a:t>지자체·제휴 사업은 계약 근거 확보 시 추가 (최대 8.0억 원)</a:t>
+              <a:t>지자체·제휴 사업은 계약 확보 후 추가 (미검증)</a:t>
             </a:r>
             <a:endParaRPr lang="en-US" sz="1200" dirty="0"/>
           </a:p>
@@ -7162,7 +7162,7 @@
                             <a:srgbClr val="1F2421"/>
                           </a:solidFill>
                         </a:rPr>
-                        <a:t>지자체·제휴 (미확정)</a:t>
+                        <a:t>지자체·제휴 (확장)</a:t>
                       </a:r>
                       <a:endParaRPr lang="en-US" sz="1100" dirty="0"/>
                     </a:p>
@@ -7205,7 +7205,7 @@
                             <a:srgbClr val="1F2421"/>
                           </a:solidFill>
                         </a:rPr>
-                        <a:t>계약 근거 확보 시 추가 (기본 목표에서 제외)</a:t>
+                        <a:t>계약 확보 시 추가하는 확장 시나리오 (미검증, 기본 목표에서 제외)</a:t>
                       </a:r>
                       <a:endParaRPr lang="en-US" sz="1100" dirty="0"/>
                     </a:p>
@@ -7766,7 +7766,7 @@
       </p:sp>
       <p:sp>
         <p:nvSpPr>
-          <p:cNvPr id="6" name="ref head 통계 · 시장"/>
+          <p:cNvPr id="6" name="ref head 통계 · 시장 · 연구"/>
           <p:cNvSpPr txBox="1"/>
           <p:nvPr/>
         </p:nvSpPr>
@@ -7794,7 +7794,7 @@
                   <a:schemeClr val="accent1"/>
                 </a:solidFill>
               </a:rPr>
-              <a:t>통계 · 시장</a:t>
+              <a:t>통계 · 시장 · 연구</a:t>
             </a:r>
             <a:endParaRPr lang="en-US" sz="1200" dirty="0"/>
           </a:p>
@@ -7802,7 +7802,7 @@
       </p:sp>
       <p:sp>
         <p:nvSpPr>
-          <p:cNvPr id="7" name="ref list 통계 · 시장"/>
+          <p:cNvPr id="7" name="ref list 통계 · 시장 · 연구"/>
           <p:cNvSpPr txBox="1"/>
           <p:nvPr/>
         </p:nvSpPr>
@@ -7822,222 +7822,305 @@
           <a:lstStyle/>
           <a:p>
             <a:pPr marL="342900" indent="-342900">
+              <a:lnSpc>
+                <a:spcPct val="112000"/>
+              </a:lnSpc>
               <a:spcAft>
-                <a:spcPts val="400"/>
+                <a:spcPts val="600"/>
               </a:spcAft>
               <a:buSzPct val="100000"/>
               <a:buFont typeface="+mj-lt"/>
               <a:buAutoNum type="arabicPeriod" startAt="1"/>
             </a:pPr>
             <a:r>
-              <a:rPr lang="en-US" sz="1050" dirty="0">
+              <a:rPr lang="en-US" sz="1050" u="sng" dirty="0">
                 <a:solidFill>
                   <a:srgbClr val="1F2421"/>
                 </a:solidFill>
-              </a:rPr>
-              <a:t>국가데이터처, 2025년 하반기 지역별고용조사 맞벌이 가구 현황 (2026.06 보도)</a:t>
+                <a:hlinkClick r:id="rId1" invalidUrl="" action="" tgtFrame="" tooltip="https://www.newsis.com/view/NISX20260618_0003673686" history="1" highlightClick="0" endSnd="0">
+                  <a:extLst>
+                    <a:ext uri="{A12FA001-AC4F-418D-AE19-62706E023703}">
+                      <ahyp:hlinkClr xmlns:ahyp="http://schemas.microsoft.com/office/drawing/2018/hyperlinkcolor" val="tx"/>
+                    </a:ext>
+                  </a:extLst>
+                </a:hlinkClick>
+              </a:rPr>
+              <a:t>국가데이터처, 2025년 하반기 지역별고용조사 맞벌이 가구 현황 (뉴시스 2026.06.18)</a:t>
             </a:r>
             <a:endParaRPr lang="en-US" sz="1050" dirty="0"/>
           </a:p>
           <a:p>
             <a:pPr marL="342900" indent="-342900">
+              <a:lnSpc>
+                <a:spcPct val="112000"/>
+              </a:lnSpc>
               <a:spcAft>
-                <a:spcPts val="400"/>
+                <a:spcPts val="600"/>
               </a:spcAft>
               <a:buSzPct val="100000"/>
               <a:buFont typeface="+mj-lt"/>
               <a:buAutoNum type="arabicPeriod" startAt="1"/>
             </a:pPr>
             <a:r>
-              <a:rPr lang="en-US" sz="1050" dirty="0">
+              <a:rPr lang="en-US" sz="1050" u="sng" dirty="0">
                 <a:solidFill>
                   <a:srgbClr val="1F2421"/>
                 </a:solidFill>
-              </a:rPr>
-              <a:t>소상공인시장진흥공단, 전통시장 실태조사 (2023 기준)</a:t>
+                <a:hlinkClick r:id="rId2" invalidUrl="" action="" tgtFrame="" tooltip="https://www.newsis.com/view/NISX20250103_0003020386" history="1" highlightClick="0" endSnd="0">
+                  <a:extLst>
+                    <a:ext uri="{A12FA001-AC4F-418D-AE19-62706E023703}">
+                      <ahyp:hlinkClr xmlns:ahyp="http://schemas.microsoft.com/office/drawing/2018/hyperlinkcolor" val="tx"/>
+                    </a:ext>
+                  </a:extLst>
+                </a:hlinkClick>
+              </a:rPr>
+              <a:t>소상공인시장진흥공단, 전통시장 실태조사 2023 (뉴시스 2025.01.03)</a:t>
             </a:r>
             <a:endParaRPr lang="en-US" sz="1050" dirty="0"/>
           </a:p>
           <a:p>
             <a:pPr marL="342900" indent="-342900">
+              <a:lnSpc>
+                <a:spcPct val="112000"/>
+              </a:lnSpc>
               <a:spcAft>
-                <a:spcPts val="400"/>
+                <a:spcPts val="600"/>
               </a:spcAft>
               <a:buSzPct val="100000"/>
               <a:buFont typeface="+mj-lt"/>
               <a:buAutoNum type="arabicPeriod" startAt="1"/>
             </a:pPr>
             <a:r>
-              <a:rPr lang="en-US" sz="1050" dirty="0">
+              <a:rPr lang="en-US" sz="1050" u="sng" dirty="0">
                 <a:solidFill>
                   <a:srgbClr val="1F2421"/>
                 </a:solidFill>
-              </a:rPr>
-              <a:t>산림청, 2024년 임산물생산조사 (2025.10)</a:t>
+                <a:hlinkClick r:id="rId3" invalidUrl="" action="" tgtFrame="" tooltip="https://www.index.go.kr/unify/idx-info.do?idxCd=1302" history="1" highlightClick="0" endSnd="0">
+                  <a:extLst>
+                    <a:ext uri="{A12FA001-AC4F-418D-AE19-62706E023703}">
+                      <ahyp:hlinkClr xmlns:ahyp="http://schemas.microsoft.com/office/drawing/2018/hyperlinkcolor" val="tx"/>
+                    </a:ext>
+                  </a:extLst>
+                </a:hlinkClick>
+              </a:rPr>
+              <a:t>산림청, 2024년 임산물생산조사 (e-나라지표)</a:t>
             </a:r>
             <a:endParaRPr lang="en-US" sz="1050" dirty="0"/>
           </a:p>
           <a:p>
             <a:pPr marL="342900" indent="-342900">
+              <a:lnSpc>
+                <a:spcPct val="112000"/>
+              </a:lnSpc>
               <a:spcAft>
-                <a:spcPts val="400"/>
+                <a:spcPts val="600"/>
               </a:spcAft>
               <a:buSzPct val="100000"/>
               <a:buFont typeface="+mj-lt"/>
               <a:buAutoNum type="arabicPeriod" startAt="1"/>
             </a:pPr>
             <a:r>
-              <a:rPr lang="en-US" sz="1050" dirty="0">
+              <a:rPr lang="en-US" sz="1050" u="sng" dirty="0">
                 <a:solidFill>
                   <a:srgbClr val="1F2421"/>
                 </a:solidFill>
-              </a:rPr>
-              <a:t>머니투데이, 배민 전통시장 장보기 입점 성과 (2026.03)</a:t>
+                <a:hlinkClick r:id="rId4" invalidUrl="" action="" tgtFrame="" tooltip="https://www.mt.co.kr/tech/2026/03/18/2026031714425925652" history="1" highlightClick="0" endSnd="0">
+                  <a:extLst>
+                    <a:ext uri="{A12FA001-AC4F-418D-AE19-62706E023703}">
+                      <ahyp:hlinkClr xmlns:ahyp="http://schemas.microsoft.com/office/drawing/2018/hyperlinkcolor" val="tx"/>
+                    </a:ext>
+                  </a:extLst>
+                </a:hlinkClick>
+              </a:rPr>
+              <a:t>머니투데이, 배민 전통시장 장보기 입점 성과 (2026.03.18)</a:t>
             </a:r>
             <a:endParaRPr lang="en-US" sz="1050" dirty="0"/>
           </a:p>
           <a:p>
             <a:pPr marL="342900" indent="-342900">
+              <a:lnSpc>
+                <a:spcPct val="112000"/>
+              </a:lnSpc>
               <a:spcAft>
-                <a:spcPts val="400"/>
+                <a:spcPts val="600"/>
               </a:spcAft>
               <a:buSzPct val="100000"/>
               <a:buFont typeface="+mj-lt"/>
               <a:buAutoNum type="arabicPeriod" startAt="1"/>
             </a:pPr>
             <a:r>
-              <a:rPr lang="en-US" sz="1050" dirty="0">
+              <a:rPr lang="en-US" sz="1050" u="sng" dirty="0">
                 <a:solidFill>
                   <a:srgbClr val="1F2421"/>
                 </a:solidFill>
-              </a:rPr>
-              <a:t>아동 편식 · 혼합 요리 연구 (KoreaScience, 2000 · 2019)</a:t>
+                <a:hlinkClick r:id="rId5" invalidUrl="" action="" tgtFrame="" tooltip="https://koreascience.or.kr/article/JAKO201931765048406.page" history="1" highlightClick="0" endSnd="0">
+                  <a:extLst>
+                    <a:ext uri="{A12FA001-AC4F-418D-AE19-62706E023703}">
+                      <ahyp:hlinkClr xmlns:ahyp="http://schemas.microsoft.com/office/drawing/2018/hyperlinkcolor" val="tx"/>
+                    </a:ext>
+                  </a:extLst>
+                </a:hlinkClick>
+              </a:rPr>
+              <a:t>정유미(2019), 유아의 나이에 따른 편식 및 식습관 실태, 한국식생활문화학회지 34(5)</a:t>
             </a:r>
             <a:endParaRPr lang="en-US" sz="1050" dirty="0"/>
           </a:p>
           <a:p>
             <a:pPr marL="342900" indent="-342900">
+              <a:lnSpc>
+                <a:spcPct val="112000"/>
+              </a:lnSpc>
               <a:spcAft>
-                <a:spcPts val="400"/>
+                <a:spcPts val="600"/>
               </a:spcAft>
               <a:buSzPct val="100000"/>
               <a:buFont typeface="+mj-lt"/>
               <a:buAutoNum type="arabicPeriod" startAt="1"/>
             </a:pPr>
             <a:r>
-              <a:rPr lang="en-US" sz="1050" dirty="0">
+              <a:rPr lang="en-US" sz="1050" u="sng" dirty="0">
                 <a:solidFill>
                   <a:srgbClr val="1F2421"/>
                 </a:solidFill>
-              </a:rPr>
-              <a:t>식품의약품안전처, 산나물 안전 섭취 안내</a:t>
+                <a:hlinkClick r:id="rId6" invalidUrl="" action="" tgtFrame="" tooltip="https://www.mfds.go.kr/webzine/201504/pdf/main.pdf" history="1" highlightClick="0" endSnd="0">
+                  <a:extLst>
+                    <a:ext uri="{A12FA001-AC4F-418D-AE19-62706E023703}">
+                      <ahyp:hlinkClr xmlns:ahyp="http://schemas.microsoft.com/office/drawing/2018/hyperlinkcolor" val="tx"/>
+                    </a:ext>
+                  </a:extLst>
+                </a:hlinkClick>
+              </a:rPr>
+              <a:t>식품의약품안전처, 산나물과 독초 구별 안내 (웹진)</a:t>
             </a:r>
             <a:endParaRPr lang="en-US" sz="1050" dirty="0"/>
           </a:p>
           <a:p>
             <a:pPr marL="342900" indent="-342900">
+              <a:lnSpc>
+                <a:spcPct val="112000"/>
+              </a:lnSpc>
               <a:spcAft>
-                <a:spcPts val="400"/>
+                <a:spcPts val="600"/>
               </a:spcAft>
               <a:buSzPct val="100000"/>
               <a:buFont typeface="+mj-lt"/>
               <a:buAutoNum type="arabicPeriod" startAt="1"/>
             </a:pPr>
             <a:r>
-              <a:rPr lang="en-US" sz="1050" dirty="0">
+              <a:rPr lang="en-US" sz="1050" u="sng" dirty="0">
                 <a:solidFill>
                   <a:srgbClr val="1F2421"/>
                 </a:solidFill>
+                <a:hlinkClick r:id="rId7" invalidUrl="" action="" tgtFrame="" tooltip="https://hanok.gongju.go.kr/cmm/fms/FileDown.do?atchFileId=FILE_0000127870Uc2bM&amp;fileSn=0" history="1" highlightClick="0" endSnd="0">
+                  <a:extLst>
+                    <a:ext uri="{A12FA001-AC4F-418D-AE19-62706E023703}">
+                      <ahyp:hlinkClr xmlns:ahyp="http://schemas.microsoft.com/office/drawing/2018/hyperlinkcolor" val="tx"/>
+                    </a:ext>
+                  </a:extLst>
+                </a:hlinkClick>
               </a:rPr>
               <a:t>중소벤처기업부 공고 제2026-143호, 예비창업패키지 수정공고</a:t>
             </a:r>
             <a:endParaRPr lang="en-US" sz="1050" dirty="0"/>
           </a:p>
+        </p:txBody>
+      </p:sp>
+      <p:sp>
+        <p:nvSpPr>
+          <p:cNvPr id="8" name="ref head 경쟁 · 기술 · 자료"/>
+          <p:cNvSpPr txBox="1"/>
+          <p:nvPr/>
+        </p:nvSpPr>
+        <p:spPr>
+          <a:xfrm>
+            <a:off x="4663440" y="1536192"/>
+            <a:ext cx="4069080" cy="274320"/>
+          </a:xfrm>
+          <a:prstGeom prst="rect">
+            <a:avLst/>
+          </a:prstGeom>
+          <a:noFill/>
+          <a:ln/>
+        </p:spPr>
+        <p:txBody>
+          <a:bodyPr wrap="square" lIns="0" tIns="0" rIns="0" bIns="0" rtlCol="0" anchor="ctr"/>
+          <a:lstStyle/>
+          <a:p>
+            <a:pPr indent="0" marL="0">
+              <a:buNone/>
+            </a:pPr>
+            <a:r>
+              <a:rPr lang="en-US" sz="1200" b="1" dirty="0">
+                <a:solidFill>
+                  <a:schemeClr val="accent1"/>
+                </a:solidFill>
+              </a:rPr>
+              <a:t>경쟁 · 기술 · 자료</a:t>
+            </a:r>
+            <a:endParaRPr lang="en-US" sz="1200" dirty="0"/>
+          </a:p>
+        </p:txBody>
+      </p:sp>
+      <p:sp>
+        <p:nvSpPr>
+          <p:cNvPr id="9" name="ref list 경쟁 · 기술 · 자료"/>
+          <p:cNvSpPr txBox="1"/>
+          <p:nvPr/>
+        </p:nvSpPr>
+        <p:spPr>
+          <a:xfrm>
+            <a:off x="4663440" y="1847088"/>
+            <a:ext cx="4069080" cy="2697480"/>
+          </a:xfrm>
+          <a:prstGeom prst="rect">
+            <a:avLst/>
+          </a:prstGeom>
+          <a:noFill/>
+          <a:ln/>
+        </p:spPr>
+        <p:txBody>
+          <a:bodyPr wrap="square" lIns="0" tIns="0" rIns="0" bIns="0" rtlCol="0" anchor="t"/>
+          <a:lstStyle/>
           <a:p>
             <a:pPr marL="342900" indent="-342900">
+              <a:lnSpc>
+                <a:spcPct val="112000"/>
+              </a:lnSpc>
               <a:spcAft>
-                <a:spcPts val="400"/>
+                <a:spcPts val="600"/>
               </a:spcAft>
               <a:buSzPct val="100000"/>
               <a:buFont typeface="+mj-lt"/>
-              <a:buAutoNum type="arabicPeriod" startAt="1"/>
-            </a:pPr>
-            <a:r>
-              <a:rPr lang="en-US" sz="1050" dirty="0">
+              <a:buAutoNum type="arabicPeriod" startAt="8"/>
+            </a:pPr>
+            <a:r>
+              <a:rPr lang="en-US" sz="1050" u="sng" dirty="0">
                 <a:solidFill>
                   <a:srgbClr val="1F2421"/>
                 </a:solidFill>
-              </a:rPr>
-              <a:t>통계청, 온라인쇼핑동향 (2024, 식품 거래액)</a:t>
+                <a:hlinkClick r:id="rId8" invalidUrl="" action="" tgtFrame="" tooltip="https://navercorp.com/media/pressReleasesDetail?seq=34203" history="1" highlightClick="0" endSnd="0">
+                  <a:extLst>
+                    <a:ext uri="{A12FA001-AC4F-418D-AE19-62706E023703}">
+                      <ahyp:hlinkClr xmlns:ahyp="http://schemas.microsoft.com/office/drawing/2018/hyperlinkcolor" val="tx"/>
+                    </a:ext>
+                  </a:extLst>
+                </a:hlinkClick>
+              </a:rPr>
+              <a:t>네이버, 스마트플레이스 AI 리뷰 관리 · 톡톡 AI FAQ 발표</a:t>
             </a:r>
             <a:endParaRPr lang="en-US" sz="1050" dirty="0"/>
           </a:p>
-        </p:txBody>
-      </p:sp>
-      <p:sp>
-        <p:nvSpPr>
-          <p:cNvPr id="8" name="ref head 경쟁 · 기술 · 자료"/>
-          <p:cNvSpPr txBox="1"/>
-          <p:nvPr/>
-        </p:nvSpPr>
-        <p:spPr>
-          <a:xfrm>
-            <a:off x="4663440" y="1536192"/>
-            <a:ext cx="4069080" cy="274320"/>
-          </a:xfrm>
-          <a:prstGeom prst="rect">
-            <a:avLst/>
-          </a:prstGeom>
-          <a:noFill/>
-          <a:ln/>
-        </p:spPr>
-        <p:txBody>
-          <a:bodyPr wrap="square" lIns="0" tIns="0" rIns="0" bIns="0" rtlCol="0" anchor="ctr"/>
-          <a:lstStyle/>
-          <a:p>
-            <a:pPr indent="0" marL="0">
-              <a:buNone/>
-            </a:pPr>
-            <a:r>
-              <a:rPr lang="en-US" sz="1200" b="1" dirty="0">
-                <a:solidFill>
-                  <a:schemeClr val="accent1"/>
-                </a:solidFill>
-              </a:rPr>
-              <a:t>경쟁 · 기술 · 자료</a:t>
-            </a:r>
-            <a:endParaRPr lang="en-US" sz="1200" dirty="0"/>
-          </a:p>
-        </p:txBody>
-      </p:sp>
-      <p:sp>
-        <p:nvSpPr>
-          <p:cNvPr id="9" name="ref list 경쟁 · 기술 · 자료"/>
-          <p:cNvSpPr txBox="1"/>
-          <p:nvPr/>
-        </p:nvSpPr>
-        <p:spPr>
-          <a:xfrm>
-            <a:off x="4663440" y="1847088"/>
-            <a:ext cx="4069080" cy="2697480"/>
-          </a:xfrm>
-          <a:prstGeom prst="rect">
-            <a:avLst/>
-          </a:prstGeom>
-          <a:noFill/>
-          <a:ln/>
-        </p:spPr>
-        <p:txBody>
-          <a:bodyPr wrap="square" lIns="0" tIns="0" rIns="0" bIns="0" rtlCol="0" anchor="t"/>
-          <a:lstStyle/>
           <a:p>
             <a:pPr marL="342900" indent="-342900">
+              <a:lnSpc>
+                <a:spcPct val="112000"/>
+              </a:lnSpc>
               <a:spcAft>
-                <a:spcPts val="400"/>
+                <a:spcPts val="600"/>
               </a:spcAft>
               <a:buSzPct val="100000"/>
               <a:buFont typeface="+mj-lt"/>
-              <a:buAutoNum type="arabicPeriod" startAt="9"/>
+              <a:buAutoNum type="arabicPeriod" startAt="8"/>
             </a:pPr>
             <a:r>
               <a:rPr lang="en-US" sz="1050" dirty="0">
@@ -8045,37 +8128,50 @@
                   <a:srgbClr val="1F2421"/>
                 </a:solidFill>
               </a:rPr>
-              <a:t>네이버, 스마트플레이스 AI 리뷰 관리 · 톡톡 AI FAQ 발표</a:t>
+              <a:t>쿠팡 · 컬리 · 어글리어스 · 당근 서비스 소개 (2026.10 확인, 자체 정리)</a:t>
             </a:r>
             <a:endParaRPr lang="en-US" sz="1050" dirty="0"/>
           </a:p>
           <a:p>
             <a:pPr marL="342900" indent="-342900">
+              <a:lnSpc>
+                <a:spcPct val="112000"/>
+              </a:lnSpc>
               <a:spcAft>
-                <a:spcPts val="400"/>
+                <a:spcPts val="600"/>
               </a:spcAft>
               <a:buSzPct val="100000"/>
               <a:buFont typeface="+mj-lt"/>
-              <a:buAutoNum type="arabicPeriod" startAt="9"/>
-            </a:pPr>
-            <a:r>
-              <a:rPr lang="en-US" sz="1050" dirty="0">
+              <a:buAutoNum type="arabicPeriod" startAt="8"/>
+            </a:pPr>
+            <a:r>
+              <a:rPr lang="en-US" sz="1050" u="sng" dirty="0">
                 <a:solidFill>
                   <a:srgbClr val="1F2421"/>
                 </a:solidFill>
-              </a:rPr>
-              <a:t>쿠팡 · 컬리 · 어글리어스 · 당근 서비스 소개 및 보도 (2026.10 확인)</a:t>
+                <a:hlinkClick r:id="rId9" invalidUrl="" action="" tgtFrame="" tooltip="https://platform.claude.com/docs/en/about-claude/pricing" history="1" highlightClick="0" endSnd="0">
+                  <a:extLst>
+                    <a:ext uri="{A12FA001-AC4F-418D-AE19-62706E023703}">
+                      <ahyp:hlinkClr xmlns:ahyp="http://schemas.microsoft.com/office/drawing/2018/hyperlinkcolor" val="tx"/>
+                    </a:ext>
+                  </a:extLst>
+                </a:hlinkClick>
+              </a:rPr>
+              <a:t>Anthropic, Claude API 가격표 (2026.10)</a:t>
             </a:r>
             <a:endParaRPr lang="en-US" sz="1050" dirty="0"/>
           </a:p>
           <a:p>
             <a:pPr marL="342900" indent="-342900">
+              <a:lnSpc>
+                <a:spcPct val="112000"/>
+              </a:lnSpc>
               <a:spcAft>
-                <a:spcPts val="400"/>
+                <a:spcPts val="600"/>
               </a:spcAft>
               <a:buSzPct val="100000"/>
               <a:buFont typeface="+mj-lt"/>
-              <a:buAutoNum type="arabicPeriod" startAt="9"/>
+              <a:buAutoNum type="arabicPeriod" startAt="8"/>
             </a:pPr>
             <a:r>
               <a:rPr lang="en-US" sz="1050" dirty="0">
@@ -8083,43 +8179,34 @@
                   <a:srgbClr val="1F2421"/>
                 </a:solidFill>
               </a:rPr>
-              <a:t>Anthropic, Claude API 가격표 (2026.10)</a:t>
+              <a:t>앱 화면: 웹 프로토타입 (매장 · 가격 · 수치는 예시 데이터)</a:t>
             </a:r>
             <a:endParaRPr lang="en-US" sz="1050" dirty="0"/>
           </a:p>
           <a:p>
             <a:pPr marL="342900" indent="-342900">
+              <a:lnSpc>
+                <a:spcPct val="112000"/>
+              </a:lnSpc>
               <a:spcAft>
-                <a:spcPts val="400"/>
+                <a:spcPts val="600"/>
               </a:spcAft>
               <a:buSzPct val="100000"/>
               <a:buFont typeface="+mj-lt"/>
-              <a:buAutoNum type="arabicPeriod" startAt="9"/>
-            </a:pPr>
-            <a:r>
-              <a:rPr lang="en-US" sz="1050" dirty="0">
+              <a:buAutoNum type="arabicPeriod" startAt="8"/>
+            </a:pPr>
+            <a:r>
+              <a:rPr lang="en-US" sz="1050" u="sng" dirty="0">
                 <a:solidFill>
                   <a:srgbClr val="1F2421"/>
                 </a:solidFill>
-              </a:rPr>
-              <a:t>앱 화면: 웹 프로토타입 (매장 · 가격 · 수치는 예시 데이터)</a:t>
-            </a:r>
-            <a:endParaRPr lang="en-US" sz="1050" dirty="0"/>
-          </a:p>
-          <a:p>
-            <a:pPr marL="342900" indent="-342900">
-              <a:spcAft>
-                <a:spcPts val="400"/>
-              </a:spcAft>
-              <a:buSzPct val="100000"/>
-              <a:buFont typeface="+mj-lt"/>
-              <a:buAutoNum type="arabicPeriod" startAt="9"/>
-            </a:pPr>
-            <a:r>
-              <a:rPr lang="en-US" sz="1050" dirty="0">
-                <a:solidFill>
-                  <a:srgbClr val="1F2421"/>
-                </a:solidFill>
+                <a:hlinkClick r:id="rId10" invalidUrl="" action="" tgtFrame="" tooltip="https://github.com/microsoft/fluentui-emoji" history="1" highlightClick="0" endSnd="0">
+                  <a:extLst>
+                    <a:ext uri="{A12FA001-AC4F-418D-AE19-62706E023703}">
+                      <ahyp:hlinkClr xmlns:ahyp="http://schemas.microsoft.com/office/drawing/2018/hyperlinkcolor" val="tx"/>
+                    </a:ext>
+                  </a:extLst>
+                </a:hlinkClick>
               </a:rPr>
               <a:t>아이콘 Microsoft Fluent Emoji (MIT) · 글꼴 Pretendard (OFL)</a:t>
             </a:r>
@@ -8157,7 +8244,7 @@
                   <a:srgbClr val="7A837D"/>
                 </a:solidFill>
               </a:rPr>
-              <a:t>전체 링크: 04_레퍼런스_나물로.md</a:t>
+              <a:t>밑줄 친 항목은 원문 링크 · 전체 목록과 확인 메모는 04_레퍼런스_나물로.md</a:t>
             </a:r>
             <a:endParaRPr lang="en-US" sz="900" dirty="0"/>
           </a:p>
@@ -9149,7 +9236,7 @@
                   <a:srgbClr val="1F2421"/>
                 </a:solidFill>
               </a:rPr>
-              <a:t>어린 자녀일수록 반찬류 편식이</a:t>
+              <a:t>대구 지역 유아 86명 조사에서도</a:t>
             </a:r>
             <a:endParaRPr lang="en-US" sz="1150" dirty="0"/>
           </a:p>
@@ -9163,7 +9250,7 @@
                   <a:srgbClr val="1F2421"/>
                 </a:solidFill>
               </a:rPr>
-              <a:t>심하다는 연구 결과 (2019)</a:t>
+              <a:t>반찬류를 꺼리는 경향 (정유미, 2019)</a:t>
             </a:r>
             <a:endParaRPr lang="en-US" sz="1150" dirty="0"/>
           </a:p>
@@ -9199,7 +9286,7 @@
                   <a:srgbClr val="7A837D"/>
                 </a:solidFill>
               </a:rPr>
-              <a:t>자료: 국가데이터처 「2025년 하반기 지역별고용조사」 맞벌이 가구 현황(2026.06 보도), 아동 편식 연구(KoreaScience, 2019)</a:t>
+              <a:t>자료: 국가데이터처 「2025년 하반기 지역별고용조사」 맞벌이 가구 현황(2026.06 보도), 정유미(2019) 「유아의 나이에 따른 편식 및 식습관 실태」 한국식생활문화학회지 34(5)</a:t>
             </a:r>
             <a:endParaRPr lang="en-US" sz="900" dirty="0"/>
           </a:p>
@@ -9383,7 +9470,7 @@
                   <a:schemeClr val="tx1"/>
                 </a:solidFill>
               </a:rPr>
-              <a:t>온라인으로 사려는 수요는 있으나, 전통시장 점포는 상품 등록·재고 관리 인력이 부족함</a:t>
+              <a:t>온라인 구매 수요는 보도로 확인되나, 점포의 상품 등록·주문 응대 부담은 인터뷰로 확인할 가설임</a:t>
             </a:r>
             <a:endParaRPr lang="en-US" sz="1300" dirty="0"/>
           </a:p>
@@ -9724,7 +9811,7 @@
                   <a:srgbClr val="1E4D3A"/>
                 </a:solidFill>
               </a:rPr>
-              <a:t>판매자가 겪는 문제</a:t>
+              <a:t>예상되는 문제 (인터뷰로 확인할 가설)</a:t>
             </a:r>
             <a:endParaRPr lang="en-US" sz="1200" dirty="0"/>
           </a:p>
@@ -9821,7 +9908,7 @@
                   <a:srgbClr val="1F2421"/>
                 </a:solidFill>
               </a:rPr>
-              <a:t>온라인 운영 인력 부족</a:t>
+              <a:t>온라인 운영 부담</a:t>
             </a:r>
             <a:endParaRPr lang="en-US" sz="1400" dirty="0"/>
           </a:p>
@@ -9857,7 +9944,7 @@
                   <a:srgbClr val="4A524D"/>
                 </a:solidFill>
               </a:rPr>
-              <a:t>사진·가격·수량을 매일 올리고 주문에 응대할 사람이 없음</a:t>
+              <a:t>상품을 올리고 주문에 응대하는 일이 늘어날 것으로 예상</a:t>
             </a:r>
             <a:endParaRPr lang="en-US" sz="1200" dirty="0"/>
           </a:p>
@@ -9977,7 +10064,7 @@
                   <a:srgbClr val="1F2421"/>
                 </a:solidFill>
               </a:rPr>
-              <a:t>손질 서비스 홍보 어려움</a:t>
+              <a:t>손질 서비스 홍보</a:t>
             </a:r>
             <a:endParaRPr lang="en-US" sz="1400" dirty="0"/>
           </a:p>
@@ -10013,7 +10100,7 @@
                   <a:srgbClr val="4A524D"/>
                 </a:solidFill>
               </a:rPr>
-              <a:t>손질·데침으로 더 좋은 가격을 받을 수 있어도 알릴 채널이 없음</a:t>
+              <a:t>손질해서 팔면 값을 더 받을 수 있어도 알릴 방법이 부족할 것</a:t>
             </a:r>
             <a:endParaRPr lang="en-US" sz="1200" dirty="0"/>
           </a:p>
@@ -10169,7 +10256,7 @@
                   <a:srgbClr val="4A524D"/>
                 </a:solidFill>
               </a:rPr>
-              <a:t>제철에 물량이 몰려 팔지 못하고 남는 재고가 생김</a:t>
+              <a:t>제철에 물량이 몰려 남는 재고가 생길 것으로 예상</a:t>
             </a:r>
             <a:endParaRPr lang="en-US" sz="1200" dirty="0"/>
           </a:p>
@@ -10840,7 +10927,7 @@
                   <a:srgbClr val="1F2421"/>
                 </a:solidFill>
               </a:rPr>
-              <a:t>매주 제철 나물 3종 + 양념 + 레시피 카드 (월 29,900원부터)</a:t>
+              <a:t>매주 제철 나물 3종 + 양념 + 레시피 카드 (예정 요금 월 29,900원부터)</a:t>
             </a:r>
             <a:endParaRPr lang="en-US" sz="1200" dirty="0"/>
           </a:p>
@@ -11444,14 +11531,14 @@
       </p:sp>
       <p:sp>
         <p:nvSpPr>
-          <p:cNvPr id="18" name="status 프로토타입 구현"/>
+          <p:cNvPr id="18" name="status 시연 구현"/>
           <p:cNvSpPr/>
           <p:nvPr/>
         </p:nvSpPr>
         <p:spPr>
           <a:xfrm>
-            <a:off x="7744968" y="1600200"/>
-            <a:ext cx="987552" cy="219456"/>
+            <a:off x="8060436" y="1600200"/>
+            <a:ext cx="672084" cy="219456"/>
           </a:xfrm>
           <a:prstGeom prst="roundRect">
             <a:avLst>
@@ -11471,14 +11558,14 @@
       </p:sp>
       <p:sp>
         <p:nvSpPr>
-          <p:cNvPr id="19" name="status text 프로토타입 구현"/>
+          <p:cNvPr id="19" name="status text 시연 구현"/>
           <p:cNvSpPr txBox="1"/>
           <p:nvPr/>
         </p:nvSpPr>
         <p:spPr>
           <a:xfrm>
-            <a:off x="7744968" y="1600200"/>
-            <a:ext cx="987552" cy="219456"/>
+            <a:off x="8060436" y="1600200"/>
+            <a:ext cx="672084" cy="219456"/>
           </a:xfrm>
           <a:prstGeom prst="rect">
             <a:avLst/>
@@ -11499,7 +11586,7 @@
                   <a:srgbClr val="1E4D3A"/>
                 </a:solidFill>
               </a:rPr>
-              <a:t>프로토타입 구현</a:t>
+              <a:t>시연 구현</a:t>
             </a:r>
             <a:endParaRPr lang="en-US" sz="950" dirty="0"/>
           </a:p>
@@ -11677,14 +11764,14 @@
       </p:sp>
       <p:sp>
         <p:nvSpPr>
-          <p:cNvPr id="25" name="status 프로토타입 구현"/>
+          <p:cNvPr id="25" name="status 시연 구현"/>
           <p:cNvSpPr/>
           <p:nvPr/>
         </p:nvSpPr>
         <p:spPr>
           <a:xfrm>
-            <a:off x="7744968" y="2606040"/>
-            <a:ext cx="987552" cy="219456"/>
+            <a:off x="8060436" y="2606040"/>
+            <a:ext cx="672084" cy="219456"/>
           </a:xfrm>
           <a:prstGeom prst="roundRect">
             <a:avLst>
@@ -11704,14 +11791,14 @@
       </p:sp>
       <p:sp>
         <p:nvSpPr>
-          <p:cNvPr id="26" name="status text 프로토타입 구현"/>
+          <p:cNvPr id="26" name="status text 시연 구현"/>
           <p:cNvSpPr txBox="1"/>
           <p:nvPr/>
         </p:nvSpPr>
         <p:spPr>
           <a:xfrm>
-            <a:off x="7744968" y="2606040"/>
-            <a:ext cx="987552" cy="219456"/>
+            <a:off x="8060436" y="2606040"/>
+            <a:ext cx="672084" cy="219456"/>
           </a:xfrm>
           <a:prstGeom prst="rect">
             <a:avLst/>
@@ -11732,7 +11819,7 @@
                   <a:srgbClr val="1E4D3A"/>
                 </a:solidFill>
               </a:rPr>
-              <a:t>프로토타입 구현</a:t>
+              <a:t>시연 구현</a:t>
             </a:r>
             <a:endParaRPr lang="en-US" sz="950" dirty="0"/>
           </a:p>
@@ -12051,7 +12138,7 @@
                   <a:srgbClr val="7A837D"/>
                 </a:solidFill>
               </a:rPr>
-              <a:t>주: 화면 속 매장·가격·예측 수치는 예시 데이터 · AI는 야생 채취 식물의 식용 여부를 판단하지 않음</a:t>
+              <a:t>주: 시연 화면의 AI 응답·매장·가격·예측 수치는 예시 데이터이며 실제 AI 호출은 검증 전 · AI는 야생 채취 식물의 식용 여부를 판단하지 않음</a:t>
             </a:r>
             <a:endParaRPr lang="en-US" sz="900" dirty="0"/>
           </a:p>
@@ -12857,7 +12944,7 @@
                   <a:srgbClr val="1E4D3A"/>
                 </a:solidFill>
               </a:rPr>
-              <a:t>결과  </a:t>
+              <a:t>시연 범위  </a:t>
             </a:r>
             <a:pPr indent="0" marL="0">
               <a:buNone/>
@@ -12868,7 +12955,7 @@
                   <a:srgbClr val="1F2421"/>
                 </a:solidFill>
               </a:rPr>
-              <a:t>메뉴 선택부터 픽업 예약까지 약 1분 (시연 기준)</a:t>
+              <a:t>추천 확인부터 픽업 예약, 판매자 접수까지의 흐름</a:t>
             </a:r>
             <a:endParaRPr lang="en-US" sz="1200" dirty="0"/>
           </a:p>
@@ -13121,7 +13208,7 @@
                   <a:schemeClr val="tx1"/>
                 </a:solidFill>
               </a:rPr>
-              <a:t>전통시장 매출 가운데 수도권 채소·나물류를 1차 목표 시장으로 설정 (비율은 가정, 파일럿에서 검증)</a:t>
+              <a:t>전통시장 매출 중 수도권 채소·나물류를 1차 목표 시장으로 설정 (비율은 가정, 공개 통계로 보완)</a:t>
             </a:r>
             <a:endParaRPr lang="en-US" sz="1300" dirty="0"/>
           </a:p>
@@ -13986,7 +14073,7 @@
                   <a:srgbClr val="1F2421"/>
                 </a:solidFill>
               </a:rPr>
-              <a:t>온라인 식품 시장(약 40조 원)은 전통시장 매출과 겹치는 부분이 있어 합산하지 않음</a:t>
+              <a:t>온라인 식품 거래는 전통시장 매출과 겹칠 수 있어 전통시장 매출만 기준으로 잡음</a:t>
             </a:r>
             <a:endParaRPr lang="en-US" sz="1150" dirty="0"/>
           </a:p>
@@ -14206,7 +14293,7 @@
                   <a:schemeClr val="tx1"/>
                 </a:solidFill>
               </a:rPr>
-              <a:t>나물 레시피·동네 매장 재고·손질 옵션·픽업 주문을 한 번의 구매 과정으로 묶는 데 집중</a:t>
+              <a:t>나물 요리를 고른 고객이 필요한 재료를 동네 매장에서 손질까지 받아 살 수 있게 하는 데 집중</a:t>
             </a:r>
             <a:endParaRPr lang="en-US" sz="1300" dirty="0"/>
           </a:p>
@@ -14421,7 +14508,7 @@
                   <a:srgbClr val="4A524D"/>
                 </a:solidFill>
               </a:rPr>
-              <a:t>배송</a:t>
+              <a:t>대상</a:t>
             </a:r>
             <a:endParaRPr lang="en-US" sz="1050" dirty="0"/>
           </a:p>
@@ -14457,7 +14544,7 @@
                   <a:srgbClr val="4A524D"/>
                 </a:solidFill>
               </a:rPr>
-              <a:t>동네</a:t>
+              <a:t>지역</a:t>
             </a:r>
             <a:endParaRPr lang="en-US" sz="1050" dirty="0"/>
           </a:p>
@@ -14471,7 +14558,7 @@
                   <a:srgbClr val="4A524D"/>
                 </a:solidFill>
               </a:rPr>
-              <a:t>상권</a:t>
+              <a:t>기반</a:t>
             </a:r>
             <a:endParaRPr lang="en-US" sz="1050" dirty="0"/>
           </a:p>
@@ -16819,7 +16906,7 @@
                   <a:srgbClr val="7A837D"/>
                 </a:solidFill>
               </a:rPr>
-              <a:t>판매자 부담 예시: 월 100건 × 1.5만 원 매장 → 수수료 6만 원 + 유료 서비스 2.9만 원 = 월 8.9만 원 (거래액의 약 6%)</a:t>
+              <a:t>주: 요금은 예정안이며 파일럿에서 검증 · 판매자 부담 예시: 월 100건 × 1.5만 원 매장 → 수수료 6만 원 + 유료 서비스 2.9만 원 = 월 8.9만 원 (거래액의 약 6%)</a:t>
             </a:r>
             <a:endParaRPr lang="en-US" sz="900" dirty="0"/>
           </a:p>

</xml_diff>

<commit_message>
namul: v4.3 — Codex 3차 리뷰 반영
- 배달: 3,500원을 시험 요금으로, 배달은 마진 없이 연결해 매출 목표에서 제외.
  파일럿은 단지 1~2곳·주 2회 저녁만 시험, 실제 비용과의 차액은 300만 원 중
  20만 원 한도 지원(가정). 수수료는 상품·손질 금액의 4%(배달비 제외)로 통일,
  '배차는 나물로' → '배달대행 연결/요청'
- 54억 원은 일반 주문 + 명절 예약을 합친 상향 목표로 표시하고 보수 시나리오
  (매장당 월 77건, 거래액 41.4억, 매출 약 2.1억)를 11번·부록 1·Q&A·01에 추가
- 출처: A14를 문화일보(서울 4,000→4,900원)와 뉴데일리(강서구 4,400→5,400원,
  인천 5,000→5,800원)로 나눠 적고, B11은 '여러 점포 상품 합배송'으로 의미를
  좁힘(여러 집 묶음배달의 근거 아님), B12 날짜·지역·행사 기간 추가
- 대본: 9·11번에서 수정 이력(구독을 뺐다) 대신 현재 선택과 검증 계획을 말함,
  3번에 판매자의 필요, 4번 문제-해결 대응 문장 교체, 11번은 첫 시장 검증 후
  확장 조건 강조. Q&A 14개(배달비 차액 질문 추가, 직접 배송·구독·비수기 답 수정)
- 프로토타입: 결제한 주문을 별도 객체로 저장해 이후 선택과 분리, 판매자 카드에
  수량·준비 마감(고른 시간 − 20분), '30분 안에 도착' 삭제, 배달 조회 안내.
  check2.js에 리뷰 재현 시나리오 추가, 화면 재캡처·시연 재녹화
- 01·04·07·09·README 갱신, AI 음성 초안 8:55

Co-Authored-By: Claude Opus 5.5 <noreply@anthropic.com>
Claude-Session: https://claude.ai/code/session_01WM2pJ2E8tXi8UPjx1jXtrm
</commit_message>
<xml_diff>
--- a/namul-platform/02_발표자료_나물로.pptx
+++ b/namul-platform/02_발표자료_나물로.pptx
@@ -120,43 +120,43 @@
   <p:extLst>
     <p:ext uri="{521415D9-36F7-43E2-AB2F-B90AF26B5E84}">
       <p14:sectionLst xmlns:p14="http://schemas.microsoft.com/office/powerpoint/2010/main">
-        <p14:section name="표지" id="{6a6b8437-10dd-09e1-5453-bc4dc4a51844}">
+        <p14:section name="표지" id="{a5990608-a50f-8baa-bd7d-fe7a88b827e0}">
           <p14:sldIdLst>
             <p14:sldId id="256"/>
           </p14:sldIdLst>
         </p14:section>
-        <p14:section name="Problem" id="{e633d8e0-7c54-6737-6dc9-872339336c90}">
+        <p14:section name="Problem" id="{5c653a87-0794-ac74-45de-831bdf52acf1}">
           <p14:sldIdLst>
             <p14:sldId id="257"/>
             <p14:sldId id="258"/>
           </p14:sldIdLst>
         </p14:section>
-        <p14:section name="Solution" id="{268d109c-36cc-cabb-c918-b72af1b268e9}">
+        <p14:section name="Solution" id="{a2d5156f-8ae3-ba52-cc25-2dbc33c4f3f6}">
           <p14:sldIdLst>
             <p14:sldId id="259"/>
             <p14:sldId id="260"/>
             <p14:sldId id="261"/>
           </p14:sldIdLst>
         </p14:section>
-        <p14:section name="Business" id="{9237e591-38fe-ce86-f882-958092585acf}">
+        <p14:section name="Business" id="{14fd5885-3df6-220b-7449-e54ab6d58036}">
           <p14:sldIdLst>
             <p14:sldId id="262"/>
             <p14:sldId id="263"/>
             <p14:sldId id="264"/>
           </p14:sldIdLst>
         </p14:section>
-        <p14:section name="Vision" id="{584da5df-0959-5f14-944b-1ce95cd793fc}">
+        <p14:section name="Vision" id="{30587351-1092-3918-c8d5-e5d660851a4a}">
           <p14:sldIdLst>
             <p14:sldId id="265"/>
             <p14:sldId id="266"/>
           </p14:sldIdLst>
         </p14:section>
-        <p14:section name="마무리" id="{54427b0f-45ed-48f3-0f89-322aa416d78a}">
+        <p14:section name="마무리" id="{cdf8e19d-ca1f-f5e7-0c73-5d0c20c25b45}">
           <p14:sldIdLst>
             <p14:sldId id="267"/>
           </p14:sldIdLst>
         </p14:section>
-        <p14:section name="부록" id="{7444866d-9637-e7fa-580e-3ced9c694bf0}">
+        <p14:section name="부록" id="{c60a6c30-da19-3276-d626-a6a1e5f9f0d1}">
           <p14:sldIdLst>
             <p14:sldId id="268"/>
             <p14:sldId id="269"/>
@@ -859,7 +859,7 @@
           <a:p>
             <a:r>
               <a:rPr lang="en-US" dirty="0"/>
-              <a:t>[0:00–0:27] 안녕하세요. 오늘 발표할 창업 아이템은 나물로입니다. 나물로는 레시피를 고른 뒤 필요한 나물을 동네 가게에 주문하고, 가게에서 찾아가거나 저녁에 배달로 받을 수 있는 서비스입니다. 온라인으로 주문하고 동네 가게에서 받는 방식이라, 흔히 O2O 서비스라고 부릅니다. 문제, 해결 방안, 사업성, 향후 계획 순서로 말씀드리겠습니다.</a:t>
+              <a:t>[0:00–0:21] 안녕하세요. 오늘 발표할 창업 아이템은 나물로입니다. 나물로는 레시피를 고른 뒤 필요한 나물을 동네 가게에 온라인으로 주문하고, 가게에서 찾아가거나 저녁에 배달로 받는 O2O 서비스입니다. 문제, 해결 방안, 사업성, 향후 계획 순서로 말씀드리겠습니다.</a:t>
             </a:r>
             <a:endParaRPr lang="en-US" dirty="0"/>
           </a:p>
@@ -947,7 +947,7 @@
           <a:p>
             <a:r>
               <a:rPr lang="en-US" dirty="0"/>
-              <a:t>[6:53–7:40] 사업화는 세 단계로 진행합니다. 1단계는 올겨울, 주거 단지 근처 전통시장 한 곳의 점포 두세 곳과 함께하는 3개월 파일럿입니다. 자기자본 300만 원으로 시작합니다. 여기서 유료 주문 100건을 목표로, 30일 재구매율, 손질 옵션 선택률, 배달 선택률과 배달 한 건당 비용, 주문당 운영 시간을 측정하겠습니다. 결과가 기대에 못 미치면 타깃 고객이나 가격을 바꿔 다시 검증하겠습니다. 2단계는 예비창업패키지 같은 정부 지원사업으로 웹앱을 정식 출시하고 명절 예약을 열며 입점 매장을 30곳으로 늘리는 것이고, 3단계는 시드 투자를 받아 수도권으로 확장하는 것입니다.</a:t>
+              <a:t>[7:01–7:48] 사업화는 세 단계로 진행합니다. 1단계는 올겨울, 주거 단지 근처 전통시장 한 곳의 점포 두세 곳과 함께하는 3개월 파일럿입니다. 자기자본 300만 원으로 시작합니다. 여기서 유료 주문 100건을 목표로, 30일 재구매율, 손질 옵션 선택률, 배달 선택률과 배달 한 건당 비용, 주문당 운영 시간을 측정하겠습니다. 결과가 기대에 못 미치면 타깃 고객이나 가격을 바꿔 다시 검증하겠습니다. 2단계는 예비창업패키지 같은 정부 지원사업으로 웹앱을 정식 출시하고 명절 예약을 열며 입점 매장을 30곳으로 늘리는 것이고, 3단계는 시드 투자를 받아 수도권으로 확장하는 것입니다.</a:t>
             </a:r>
             <a:endParaRPr lang="en-US" dirty="0"/>
           </a:p>
@@ -1035,7 +1035,7 @@
           <a:p>
             <a:r>
               <a:rPr lang="en-US" dirty="0"/>
-              <a:t>[7:40–8:22] 3년 차 목표는 거래액 54억 원, 매출 약 2.6억 원입니다. 구독을 빼면서 매출 목표는 줄었지만, 근거가 확인되지 않은 수익에 기대지 않으려고 했습니다. 지자체 사업이나 제휴 매출도 계약을 확보하면 그때 더하겠습니다. 숫자는 모두 가정이라, 파일럿이 끝나면 실제 데이터로 다시 계산하겠습니다. 이후에는 나물에서 제철 농산물 전체로 품목을 넓히고, 산지 직거래와 건조 나물 해외 판매로 확장하려고 합니다. 이를 통해 전통시장의 매출을 늘리고, 아이들이 채소 반찬을 더 쉽게 먹도록 돕는 것이 목표입니다.</a:t>
+              <a:t>[7:48–8:32] 3년 차 목표는 거래액 54억 원, 매출 약 2.6억 원입니다. 매출 목표는 주문 수수료와 판매자 유료 서비스로 계산했고, 지자체 사업이나 제휴 매출은 계약을 확보한 뒤 반영하겠습니다. 보수적으로 매장당 월 77건으로 잡으면 매출은 약 2.1억 원이고, 숫자는 모두 가정이라 파일럿이 끝나면 실제 데이터로 다시 계산하겠습니다. 확장은 첫 시장에서 재구매와 주문당 운영비를 확인한 뒤, 인접 시장과 제철 농산물 전체로 넓혀 가겠습니다. 이를 통해 전통시장의 매출을 늘리고, 아이들이 채소 반찬을 더 쉽게 먹도록 돕는 것이 목표입니다.</a:t>
             </a:r>
             <a:endParaRPr lang="en-US" dirty="0"/>
           </a:p>
@@ -1123,7 +1123,7 @@
           <a:p>
             <a:r>
               <a:rPr lang="en-US" dirty="0"/>
-              <a:t>[8:22–8:44] 정리하겠습니다. 나물로는 바쁜 맞벌이 가정에는 레시피와 동네 매장 픽업, 저녁 배달을, 전통시장 판매자에게는 온라인 판매 채널을 제공하는 서비스입니다. 먼저 시장 한 곳에서 사람들이 실제로 주문하고 다시 찾아오는지 확인해 보겠습니다. 들어 주셔서 감사합니다.</a:t>
+              <a:t>[8:32–8:54] 정리하겠습니다. 나물로는 바쁜 맞벌이 가정에는 레시피와 동네 매장 픽업, 저녁 배달을, 전통시장 판매자에게는 온라인 판매 채널을 제공하는 서비스입니다. 먼저 시장 한 곳에서 사람들이 실제로 주문하고 다시 찾아오는지 확인해 보겠습니다. 들어 주셔서 감사합니다.</a:t>
             </a:r>
             <a:endParaRPr lang="en-US" dirty="0"/>
           </a:p>
@@ -1387,7 +1387,7 @@
           <a:p>
             <a:r>
               <a:rPr lang="en-US" dirty="0"/>
-              <a:t>[0:27–1:25] 먼저 고객 쪽 문제입니다. 처음에는 전통시장 근처에 살면서 아이를 키우는 맞벌이 가정을 대상으로 생각했습니다. 18세 미만 자녀를 둔 부부 가구 가운데 맞벌이 비율은 작년에 60.4%로, 처음 60%를 넘었습니다. 여섯 시에 퇴근한 부모가 일곱 시 전에 아이 저녁을 차려야 하는 상황을 떠올리시면 됩니다. 장을 보고 요리할 시간이 부족하고, 아이가 채소 반찬을 잘 먹지 않아 메뉴 고르기도 어렵습니다. 나물은 다듬고 데치는 손질이 번거롭고, 마트나 온라인몰은 한 단, 한 봉지 단위라 조금만 사기도 불편합니다. 대구 지역 유아 86명을 조사한 연구에서도 반찬류를 꺼리는 경향이 나타났습니다. 그래서 무엇을 어디서 사서 어떻게 해 먹을지를 한 번에 알려 주는 서비스가 필요하다고 봤습니다.</a:t>
+              <a:t>[0:21–1:19] 먼저 고객 쪽 문제입니다. 처음에는 전통시장 근처에 살면서 아이를 키우는 맞벌이 가정을 대상으로 생각했습니다. 18세 미만 자녀를 둔 부부 가구 가운데 맞벌이 비율은 작년에 60.4%로, 처음 60%를 넘었습니다. 여섯 시에 퇴근한 부모가 일곱 시 전에 아이 저녁을 차려야 하는 상황을 떠올리시면 됩니다. 장을 보고 요리할 시간이 부족하고, 아이가 채소 반찬을 잘 먹지 않아 메뉴 고르기도 어렵습니다. 나물은 다듬고 데치는 손질이 번거롭고, 마트나 온라인몰은 한 단, 한 봉지 단위라 조금만 사기도 불편합니다. 대구 지역 유아 86명을 조사한 연구에서도 반찬류를 꺼리는 경향이 나타났습니다. 그래서 무엇을 어디서 사서 어떻게 해 먹을지를 한 번에 알려 주는 서비스가 필요하다고 봤습니다.</a:t>
             </a:r>
             <a:endParaRPr lang="en-US" dirty="0"/>
           </a:p>
@@ -1475,7 +1475,7 @@
           <a:p>
             <a:r>
               <a:rPr lang="en-US" dirty="0"/>
-              <a:t>[1:25–2:10] 다음은 판매자 쪽입니다. 전국 전통시장은 약 1,400곳, 연매출은 28.7조 원 규모입니다. 배민 전통시장 장보기에 입점한 점포의 매출이 1년 사이 196% 늘었다는 보도를 보면, 시장 상품을 온라인으로 사려는 수요는 있다고 판단했습니다. 다만 상인이 상품을 올리고 주문까지 직접 관리하려면 일이 꽤 늘어날 것으로 봤습니다. 손질해서 팔면 값을 더 받을 수 있는데도 이를 알릴 방법이 마땅치 않고, 제철에는 물량이 몰려 재고 부담도 클 것으로 예상합니다. 이 부분은 아직 가설이라서, 시장 상인 인터뷰로 실제 부담을 확인하려고 합니다.</a:t>
+              <a:t>[1:19–2:14] 다음은 판매자 쪽입니다. 전국 전통시장은 약 1,400곳, 연매출은 28.7조 원 규모입니다. 배민 전통시장 장보기에 입점한 점포의 매출이 1년 사이 196% 늘었다는 보도를 보면, 시장 상품을 온라인으로 사려는 수요는 있다고 판단했습니다. 다만 상인이 상품을 올리고 주문까지 직접 관리하려면 일이 꽤 늘어날 것으로 봤습니다. 손질해서 팔면 값을 더 받을 수 있는데도 이를 알릴 방법이 마땅치 않고, 제철에는 물량이 몰려 재고 부담도 클 것으로 예상합니다. 그래서 판매자에게는 적은 입력으로 상품을 올리고, 손질 서비스를 알리고, 미리 주문을 받을 수 있는 통로가 필요하다고 봤습니다. 이 부분은 아직 가설이라서, 시장 상인 인터뷰로 실제 부담을 확인하려고 합니다.</a:t>
             </a:r>
             <a:endParaRPr lang="en-US" dirty="0"/>
           </a:p>
@@ -1563,7 +1563,7 @@
           <a:p>
             <a:r>
               <a:rPr lang="en-US" dirty="0"/>
-              <a:t>[2:10–3:08] 그래서 나물로는 세 단계로 서비스를 제공합니다. 첫째, 제철 나물 정보와 손질법, 레시피를 보여 주고, 아이가 잘 먹는 메뉴를 따로 추천합니다. 둘째, 레시피 재료 가운데 집에 없는 것만 골라 장바구니에 담습니다. 셋째, 반경 3km 안의 전통시장, 로컬푸드 매장, 반찬가게 중 한 곳을 고르고, 가게에서 찾아갈지 저녁에 배달받을지 정합니다. 배달은 배달대행을 연결해 저녁 시간대 주문을 묶어 보내고, 사장님은 포장만 하면 됩니다. 손질이나 데침을 원하면 매장에서 추가 요금을 받고 처리해 주고, 설 차례 나물처럼 주문이 몰리는 날은 미리 예약을 받습니다. 정리하면 고객의 시간 부족은 저녁 배달로, 손질 부담은 손질 옵션으로, 아이 반찬 고민은 메뉴 추천으로 풀고, 판매자는 배달 인력 없이 온라인 주문을 받게 됩니다.</a:t>
+              <a:t>[2:14–3:11] 그래서 나물로는 세 단계로 서비스를 제공합니다. 첫째, 제철 나물 정보와 손질법, 레시피를 보여 주고, 아이가 잘 먹는 메뉴를 따로 추천합니다. 둘째, 레시피 재료 가운데 집에 없는 것만 골라 장바구니에 담습니다. 셋째, 반경 3km 안의 전통시장, 로컬푸드 매장, 반찬가게 중 한 곳을 고르고, 가게에서 찾아갈지 저녁에 배달받을지 정합니다. 배달을 고르면 가게에서 상품을 준비하고, 나물로가 배달대행에 배달을 요청합니다. 손질이나 데침을 원하면 매장에서 추가 요금을 받고 처리해 주고, 설 차례 나물처럼 주문이 몰리는 날은 미리 예약을 받습니다. 정리하면 고객은 메뉴 추천과 손질 옵션, 저녁 배달로 준비 시간을 줄이고, 판매자는 메시지 상품 등록과 예약 주문으로 판매를 미리 준비할 수 있습니다.</a:t>
             </a:r>
             <a:endParaRPr lang="en-US" dirty="0"/>
           </a:p>
@@ -1651,7 +1651,7 @@
           <a:p>
             <a:r>
               <a:rPr lang="en-US" dirty="0"/>
-              <a:t>[3:08–4:00] AI는 세 가지 업무에 적용하려고 합니다. 첫째는 고객용 레시피 추천입니다. 아이 나이나 집에 있는 재료를 입력하면, 근처 매장 재고로 만들 수 있는 반찬을 추천합니다. 둘째는 판매자용 상품 등록입니다. 사장님이 평소처럼 참나물 스무 단, 한 단 3,500원이라고 메시지를 보내면, AI가 품목과 수량, 가격으로 정리하고, 사장님이 확인을 눌러야 앱에 올라갑니다. 셋째는 발주량 추천과 마감 할인인데, 이 기능은 주문 데이터가 쌓인 뒤에 도입할 계획입니다. 앞의 두 기능은 시연 화면까지 만들어 두었고, 화면의 응답과 매장, 가격은 예시 데이터입니다. 또 안전을 위해 AI가 야생에서 캔 식물의 식용 여부는 판단하지 않도록 했습니다.</a:t>
+              <a:t>[3:11–4:03] AI는 세 가지 업무에 적용하려고 합니다. 첫째는 고객용 레시피 추천입니다. 아이 나이나 집에 있는 재료를 입력하면, 근처 매장 재고로 만들 수 있는 반찬을 추천합니다. 둘째는 판매자용 상품 등록입니다. 사장님이 평소처럼 참나물 스무 단, 한 단 3,500원이라고 메시지를 보내면, AI가 품목과 수량, 가격으로 정리하고, 사장님이 확인을 눌러야 앱에 올라갑니다. 셋째는 발주량 추천과 마감 할인인데, 이 기능은 주문 데이터가 쌓인 뒤에 도입할 계획입니다. 앞의 두 기능은 시연 화면까지 만들어 두었고, 화면의 응답과 매장, 가격은 예시 데이터입니다. 또 안전을 위해 AI가 야생에서 캔 식물의 식용 여부는 판단하지 않도록 했습니다.</a:t>
             </a:r>
             <a:endParaRPr lang="en-US" dirty="0"/>
           </a:p>
@@ -1739,7 +1739,7 @@
           <a:p>
             <a:r>
               <a:rPr lang="en-US" dirty="0"/>
-              <a:t>[4:00–4:41] 웹 프로토타입으로 사용 흐름을 보여 드리겠습니다. 맞벌이 부모가 다섯 살 아이와 먹을 순한 반찬을 물으면, 추천 메뉴 세 가지가 나옵니다. 참나물 레시피를 보고 재료를 담은 뒤, 600미터 떨어진 시장 가게에서 손질 옵션을 고릅니다. 받는 방법은 가게 픽업과 저녁 배달 중에 고를 수 있는데, 여기서는 저녁 6시 픽업을 골랐습니다. 판매자 화면에서는 들어온 주문을 확인하고 접수합니다. 시연 속 AI 응답과 주문 데이터는 예시이고, 실제 결제와 배달 연동은 파일럿에서 검증하겠습니다.</a:t>
+              <a:t>[4:03–4:44] 웹 프로토타입으로 사용 흐름을 보여 드리겠습니다. 맞벌이 부모가 다섯 살 아이와 먹을 순한 반찬을 물으면, 추천 메뉴 세 가지가 나옵니다. 참나물 레시피를 보고 재료를 담은 뒤, 600미터 떨어진 시장 가게에서 손질 옵션을 고릅니다. 받는 방법은 가게 픽업과 저녁 배달 중에 고를 수 있는데, 여기서는 저녁 6시 픽업을 골랐습니다. 판매자 화면에서는 들어온 주문을 확인하고 접수합니다. 시연 속 AI 응답과 주문 데이터는 예시이고, 실제 결제와 배달 연동은 파일럿에서 검증하겠습니다.</a:t>
             </a:r>
             <a:endParaRPr lang="en-US" dirty="0"/>
           </a:p>
@@ -1827,7 +1827,7 @@
           <a:p>
             <a:r>
               <a:rPr lang="en-US" dirty="0"/>
-              <a:t>[4:41–5:23] 다음은 시장 규모입니다. 전통시장 전체 매출 28.7조 원에서 수도권 비중 40%와 채소, 나물류 비중 15%를 가정해, 1차 목표 시장을 약 1.7조 원으로 잡았습니다. 온라인 식품 거래와는 겹치는 부분이 있어서, 전통시장 매출만 기준으로 삼았습니다. 수도권과 품목 비중은 공개 통계로 보완하고, 파일럿에서는 참여 점포의 나물 매출과 주문 가능성을 확인하겠습니다. 3년 차 목표 거래액은 입점 매장 300곳이 한 달에 100건씩, 평균 1만 5천 원 주문을 받는다고 가정해 54억 원으로 정했습니다.</a:t>
+              <a:t>[4:44–5:28] 다음은 시장 규모입니다. 전통시장 전체 매출 28.7조 원에서 수도권 비중 40%와 채소, 나물류 비중 15%를 가정해, 1차 목표 시장을 약 1.7조 원으로 잡았습니다. 온라인 식품 거래와는 겹치는 부분이 있어서, 전통시장 매출만 기준으로 삼았습니다. 수도권과 품목 비중은 공개 통계로 보완하고, 파일럿에서는 참여 점포의 나물 매출과 주문 가능성을 확인하겠습니다. 3년 차 목표 거래액은 입점 매장 300곳이 일반 주문과 명절 예약을 합쳐 한 달에 100건씩, 평균 1만 5천 원 주문을 받는다고 가정해 54억 원으로 정했습니다.</a:t>
             </a:r>
             <a:endParaRPr lang="en-US" dirty="0"/>
           </a:p>
@@ -1915,7 +1915,7 @@
           <a:p>
             <a:r>
               <a:rPr lang="en-US" dirty="0"/>
-              <a:t>[5:23–6:01] 경쟁 서비스를 보면, 쿠팡과 컬리는 전국 배송, 레시피 앱과 유튜브는 콘텐츠에 강하고, 배민과 네이버는 동네 가게 주문과 판매자 도구를 갖추고 있습니다. 나물로는 나물 요리를 고른 사람이 필요한 재료를 동네에서 손질까지 받아 살 수 있도록 만드는 데 집중했습니다. 손질과 데침 옵션은 판매자에게는 추가 매출이 되고, 고객에게는 조리 시간을 줄여 줍니다. 큰 플랫폼과 정면으로 경쟁하기보다, 상인들이 함께 쓸 수 있는 나물 전문 판매 채널로 자리 잡는 것이 목표입니다.</a:t>
+              <a:t>[5:28–6:07] 경쟁 서비스를 보면, 쿠팡과 컬리는 전국 배송, 레시피 앱과 유튜브는 콘텐츠에 강하고, 배민과 네이버는 동네 가게 주문과 판매자 도구를 갖추고 있습니다. 나물로는 나물 요리를 고른 사람이 필요한 재료를 동네에서 손질까지 받아 살 수 있도록 만드는 데 집중했습니다. 손질과 데침 옵션은 판매자에게는 추가 매출이 되고, 고객에게는 조리 시간을 줄여 줍니다. 큰 플랫폼과 정면으로 경쟁하기보다, 상인들이 함께 쓸 수 있는 나물 전문 판매 채널로 자리 잡는 것이 목표입니다.</a:t>
             </a:r>
             <a:endParaRPr lang="en-US" dirty="0"/>
           </a:p>
@@ -2003,7 +2003,7 @@
           <a:p>
             <a:r>
               <a:rPr lang="en-US" dirty="0"/>
-              <a:t>[6:01–6:53] 수익 모델은 세 가지입니다. 요금은 모두 예정안이고, 파일럿에서 검증할 계획입니다. 기본은 주문 금액의 4% 중개 수수료이고, 판매자가 선택하는 월 2만 9천 원의 유료 서비스와 제휴 광고를 더합니다. 배달비 3,500원은 고객이 내고 배달대행 비용으로 그대로 나가기 때문에 수익으로 잡지 않았습니다. 보도된 배달대행 기본료가 건당 4천 원이 넘어서, 여러 집을 묶어 보내 원가를 맞추는 것이 과제입니다. 정기구독은 나물만으로 매주 받을 이유가 약하고 운영 부담이 커서 빼고, 명절 예약 주문으로 대신했습니다. 판매자 부담은 월 100건 매장 기준 거래액의 약 6%이고, 전통시장 점포는 첫 6개월 수수료를 받지 않겠습니다.</a:t>
+              <a:t>[6:07–7:01] 수익 모델은 세 가지입니다. 요금은 모두 예정안이고, 파일럿에서 검증할 계획입니다. 기본은 상품과 손질 금액의 4%를 받는 중개 수수료이고, 판매자가 선택하는 월 2만 9천 원의 유료 서비스와 제휴 광고를 더합니다. 배달은 별도 마진 없이 연결할 계획이라, 배달비는 매출 목표에서 제외했습니다. 배달비 3,500원은 시험 요금이고, 보도된 일부 배달대행 기본료는 이보다 높아서, 차액은 파일럿 예산 안에서 한도를 정해 부담하겠습니다. 초기에는 개별 주문과 명절 예약에 집중하고, 정기구독은 반복 구매 수요를 확인한 뒤 검토하겠습니다. 판매자 부담은 월 100건 매장 기준 거래액의 약 6%이고, 전통시장 점포는 첫 6개월 수수료를 받지 않겠습니다.</a:t>
             </a:r>
             <a:endParaRPr lang="en-US" dirty="0"/>
           </a:p>
@@ -3983,7 +3983,7 @@
                             <a:srgbClr val="1F2421"/>
                           </a:solidFill>
                         </a:rPr>
-                        <a:t>(배달대행 수동 호출)</a:t>
+                        <a:t>(배달은 단지 한정 시험)</a:t>
                       </a:r>
                       <a:endParaRPr lang="en-US" sz="1200" dirty="0"/>
                     </a:p>
@@ -4175,6 +4175,20 @@
                       </a:r>
                       <a:endParaRPr lang="en-US" sz="1200" dirty="0"/>
                     </a:p>
+                    <a:p>
+                      <a:pPr algn="l" indent="0" marL="0">
+                        <a:buNone/>
+                      </a:pPr>
+                      <a:r>
+                        <a:rPr lang="en-US" sz="1200" dirty="0">
+                          <a:solidFill>
+                            <a:srgbClr val="1F2421"/>
+                          </a:solidFill>
+                        </a:rPr>
+                        <a:t>(배달 차액 20만 원 한도)</a:t>
+                      </a:r>
+                      <a:endParaRPr lang="en-US" sz="1200" dirty="0"/>
+                    </a:p>
                   </a:txBody>
                   <a:tcPr marL="91440" marR="91440" marT="36576" marB="36576" anchor="ctr">
                     <a:lnL w="0" cap="flat" cmpd="sng" algn="ctr">
@@ -4804,7 +4818,7 @@
                   <a:schemeClr val="tx1"/>
                 </a:solidFill>
               </a:rPr>
-              <a:t>3년차 거래액 54억 원·매출 약 2.6억 원(기본 수익원 기준)을 목표로, 품목·산지·해외로 확장</a:t>
+              <a:t>3년차 거래액 54억 원·매출 약 2.6억 원을 목표로, 첫 시장에서 재구매와 운영비를 확인한 뒤 확장</a:t>
             </a:r>
             <a:endParaRPr lang="en-US" sz="1300" dirty="0"/>
           </a:p>
@@ -4881,7 +4895,7 @@
                   <a:srgbClr val="1E4D3A"/>
                 </a:solidFill>
               </a:rPr>
-              <a:t>3년차 매출(기본) 약 2.6억 원</a:t>
+              <a:t>3년차 매출 목표 약 2.6억 원</a:t>
             </a:r>
             <a:endParaRPr lang="en-US" sz="1200" dirty="0"/>
           </a:p>
@@ -4895,7 +4909,7 @@
                   <a:srgbClr val="1F2421"/>
                 </a:solidFill>
               </a:rPr>
-              <a:t>수수료 2.2 + 판매자 서비스 0.4 (억 원), 배달비는 제외</a:t>
+              <a:t>수수료 2.2 + 판매자 서비스 0.4 (억 원), 배달비 제외</a:t>
             </a:r>
             <a:endParaRPr lang="en-US" sz="1200" dirty="0"/>
           </a:p>
@@ -4909,7 +4923,7 @@
                   <a:srgbClr val="1F2421"/>
                 </a:solidFill>
               </a:rPr>
-              <a:t>지자체·제휴 사업은 계약 확보 후 추가 (미검증)</a:t>
+              <a:t>보수 시나리오(매장당 월 77건) 약 2.1억 원</a:t>
             </a:r>
             <a:endParaRPr lang="en-US" sz="1200" dirty="0"/>
           </a:p>
@@ -4992,6 +5006,182 @@
                             <a:srgbClr val="1F2421"/>
                           </a:solidFill>
                         </a:rPr>
+                        <a:t>확장 조건</a:t>
+                      </a:r>
+                      <a:endParaRPr lang="en-US" sz="1200" dirty="0"/>
+                    </a:p>
+                  </a:txBody>
+                  <a:tcPr marL="91440" marR="91440" marT="36576" marB="36576" anchor="ctr">
+                    <a:lnL w="0" cap="flat" cmpd="sng" algn="ctr">
+                      <a:noFill/>
+                    </a:lnL>
+                    <a:lnR w="0" cap="flat" cmpd="sng" algn="ctr">
+                      <a:noFill/>
+                    </a:lnR>
+                    <a:lnT w="0" cap="flat" cmpd="sng" algn="ctr">
+                      <a:noFill/>
+                    </a:lnT>
+                    <a:lnB w="9525" cap="flat" cmpd="sng" algn="ctr">
+                      <a:solidFill>
+                        <a:srgbClr val="D9DED9"/>
+                      </a:solidFill>
+                      <a:prstDash val="solid"/>
+                      <a:round/>
+                      <a:headEnd type="none" w="med" len="med"/>
+                      <a:tailEnd type="none" w="med" len="med"/>
+                    </a:lnB>
+                    <a:solidFill>
+                      <a:srgbClr val="F2F4F2"/>
+                    </a:solidFill>
+                  </a:tcPr>
+                </a:tc>
+                <a:tc>
+                  <a:txBody>
+                    <a:bodyPr/>
+                    <a:lstStyle/>
+                    <a:p>
+                      <a:pPr algn="l" indent="0" marL="0">
+                        <a:buNone/>
+                      </a:pPr>
+                      <a:r>
+                        <a:rPr lang="en-US" sz="1200" dirty="0">
+                          <a:solidFill>
+                            <a:srgbClr val="1F2421"/>
+                          </a:solidFill>
+                        </a:rPr>
+                        <a:t>첫 시장의 재구매·운영비 확인</a:t>
+                      </a:r>
+                      <a:endParaRPr lang="en-US" sz="1200" dirty="0"/>
+                    </a:p>
+                  </a:txBody>
+                  <a:tcPr marL="91440" marR="91440" marT="36576" marB="36576" anchor="ctr">
+                    <a:lnL w="0" cap="flat" cmpd="sng" algn="ctr">
+                      <a:noFill/>
+                    </a:lnL>
+                    <a:lnR w="0" cap="flat" cmpd="sng" algn="ctr">
+                      <a:noFill/>
+                    </a:lnR>
+                    <a:lnT w="0" cap="flat" cmpd="sng" algn="ctr">
+                      <a:noFill/>
+                    </a:lnT>
+                    <a:lnB w="9525" cap="flat" cmpd="sng" algn="ctr">
+                      <a:solidFill>
+                        <a:srgbClr val="D9DED9"/>
+                      </a:solidFill>
+                      <a:prstDash val="solid"/>
+                      <a:round/>
+                      <a:headEnd type="none" w="med" len="med"/>
+                      <a:tailEnd type="none" w="med" len="med"/>
+                    </a:lnB>
+                    <a:solidFill>
+                      <a:srgbClr val="FFFFFF"/>
+                    </a:solidFill>
+                  </a:tcPr>
+                </a:tc>
+              </a:tr>
+              <a:tr h="384048">
+                <a:tc>
+                  <a:txBody>
+                    <a:bodyPr/>
+                    <a:lstStyle/>
+                    <a:p>
+                      <a:pPr algn="ctr" indent="0" marL="0">
+                        <a:buNone/>
+                      </a:pPr>
+                      <a:r>
+                        <a:rPr lang="en-US" sz="1200" b="1" dirty="0">
+                          <a:solidFill>
+                            <a:srgbClr val="1F2421"/>
+                          </a:solidFill>
+                        </a:rPr>
+                        <a:t>지역 확대</a:t>
+                      </a:r>
+                      <a:endParaRPr lang="en-US" sz="1200" dirty="0"/>
+                    </a:p>
+                  </a:txBody>
+                  <a:tcPr marL="91440" marR="91440" marT="36576" marB="36576" anchor="ctr">
+                    <a:lnL w="0" cap="flat" cmpd="sng" algn="ctr">
+                      <a:noFill/>
+                    </a:lnL>
+                    <a:lnR w="0" cap="flat" cmpd="sng" algn="ctr">
+                      <a:noFill/>
+                    </a:lnR>
+                    <a:lnT w="0" cap="flat" cmpd="sng" algn="ctr">
+                      <a:noFill/>
+                    </a:lnT>
+                    <a:lnB w="9525" cap="flat" cmpd="sng" algn="ctr">
+                      <a:solidFill>
+                        <a:srgbClr val="D9DED9"/>
+                      </a:solidFill>
+                      <a:prstDash val="solid"/>
+                      <a:round/>
+                      <a:headEnd type="none" w="med" len="med"/>
+                      <a:tailEnd type="none" w="med" len="med"/>
+                    </a:lnB>
+                    <a:solidFill>
+                      <a:srgbClr val="F2F4F2"/>
+                    </a:solidFill>
+                  </a:tcPr>
+                </a:tc>
+                <a:tc>
+                  <a:txBody>
+                    <a:bodyPr/>
+                    <a:lstStyle/>
+                    <a:p>
+                      <a:pPr algn="l" indent="0" marL="0">
+                        <a:buNone/>
+                      </a:pPr>
+                      <a:r>
+                        <a:rPr lang="en-US" sz="1200" dirty="0">
+                          <a:solidFill>
+                            <a:srgbClr val="1F2421"/>
+                          </a:solidFill>
+                        </a:rPr>
+                        <a:t>인접 시장·주거 단지 → 수도권</a:t>
+                      </a:r>
+                      <a:endParaRPr lang="en-US" sz="1200" dirty="0"/>
+                    </a:p>
+                  </a:txBody>
+                  <a:tcPr marL="91440" marR="91440" marT="36576" marB="36576" anchor="ctr">
+                    <a:lnL w="0" cap="flat" cmpd="sng" algn="ctr">
+                      <a:noFill/>
+                    </a:lnL>
+                    <a:lnR w="0" cap="flat" cmpd="sng" algn="ctr">
+                      <a:noFill/>
+                    </a:lnR>
+                    <a:lnT w="0" cap="flat" cmpd="sng" algn="ctr">
+                      <a:noFill/>
+                    </a:lnT>
+                    <a:lnB w="9525" cap="flat" cmpd="sng" algn="ctr">
+                      <a:solidFill>
+                        <a:srgbClr val="D9DED9"/>
+                      </a:solidFill>
+                      <a:prstDash val="solid"/>
+                      <a:round/>
+                      <a:headEnd type="none" w="med" len="med"/>
+                      <a:tailEnd type="none" w="med" len="med"/>
+                    </a:lnB>
+                    <a:solidFill>
+                      <a:srgbClr val="FFFFFF"/>
+                    </a:solidFill>
+                  </a:tcPr>
+                </a:tc>
+              </a:tr>
+              <a:tr h="384048">
+                <a:tc>
+                  <a:txBody>
+                    <a:bodyPr/>
+                    <a:lstStyle/>
+                    <a:p>
+                      <a:pPr algn="ctr" indent="0" marL="0">
+                        <a:buNone/>
+                      </a:pPr>
+                      <a:r>
+                        <a:rPr lang="en-US" sz="1200" b="1" dirty="0">
+                          <a:solidFill>
+                            <a:srgbClr val="1F2421"/>
+                          </a:solidFill>
+                        </a:rPr>
                         <a:t>품목 확대</a:t>
                       </a:r>
                       <a:endParaRPr lang="en-US" sz="1200" dirty="0"/>
@@ -5065,182 +5255,6 @@
                   </a:tcPr>
                 </a:tc>
               </a:tr>
-              <a:tr h="384048">
-                <a:tc>
-                  <a:txBody>
-                    <a:bodyPr/>
-                    <a:lstStyle/>
-                    <a:p>
-                      <a:pPr algn="ctr" indent="0" marL="0">
-                        <a:buNone/>
-                      </a:pPr>
-                      <a:r>
-                        <a:rPr lang="en-US" sz="1200" b="1" dirty="0">
-                          <a:solidFill>
-                            <a:srgbClr val="1F2421"/>
-                          </a:solidFill>
-                        </a:rPr>
-                        <a:t>산지 직거래</a:t>
-                      </a:r>
-                      <a:endParaRPr lang="en-US" sz="1200" dirty="0"/>
-                    </a:p>
-                  </a:txBody>
-                  <a:tcPr marL="91440" marR="91440" marT="36576" marB="36576" anchor="ctr">
-                    <a:lnL w="0" cap="flat" cmpd="sng" algn="ctr">
-                      <a:noFill/>
-                    </a:lnL>
-                    <a:lnR w="0" cap="flat" cmpd="sng" algn="ctr">
-                      <a:noFill/>
-                    </a:lnR>
-                    <a:lnT w="0" cap="flat" cmpd="sng" algn="ctr">
-                      <a:noFill/>
-                    </a:lnT>
-                    <a:lnB w="9525" cap="flat" cmpd="sng" algn="ctr">
-                      <a:solidFill>
-                        <a:srgbClr val="D9DED9"/>
-                      </a:solidFill>
-                      <a:prstDash val="solid"/>
-                      <a:round/>
-                      <a:headEnd type="none" w="med" len="med"/>
-                      <a:tailEnd type="none" w="med" len="med"/>
-                    </a:lnB>
-                    <a:solidFill>
-                      <a:srgbClr val="F2F4F2"/>
-                    </a:solidFill>
-                  </a:tcPr>
-                </a:tc>
-                <a:tc>
-                  <a:txBody>
-                    <a:bodyPr/>
-                    <a:lstStyle/>
-                    <a:p>
-                      <a:pPr algn="l" indent="0" marL="0">
-                        <a:buNone/>
-                      </a:pPr>
-                      <a:r>
-                        <a:rPr lang="en-US" sz="1200" dirty="0">
-                          <a:solidFill>
-                            <a:srgbClr val="1F2421"/>
-                          </a:solidFill>
-                        </a:rPr>
-                        <a:t>산채 농가 → 동네 매장 → 고객</a:t>
-                      </a:r>
-                      <a:endParaRPr lang="en-US" sz="1200" dirty="0"/>
-                    </a:p>
-                  </a:txBody>
-                  <a:tcPr marL="91440" marR="91440" marT="36576" marB="36576" anchor="ctr">
-                    <a:lnL w="0" cap="flat" cmpd="sng" algn="ctr">
-                      <a:noFill/>
-                    </a:lnL>
-                    <a:lnR w="0" cap="flat" cmpd="sng" algn="ctr">
-                      <a:noFill/>
-                    </a:lnR>
-                    <a:lnT w="0" cap="flat" cmpd="sng" algn="ctr">
-                      <a:noFill/>
-                    </a:lnT>
-                    <a:lnB w="9525" cap="flat" cmpd="sng" algn="ctr">
-                      <a:solidFill>
-                        <a:srgbClr val="D9DED9"/>
-                      </a:solidFill>
-                      <a:prstDash val="solid"/>
-                      <a:round/>
-                      <a:headEnd type="none" w="med" len="med"/>
-                      <a:tailEnd type="none" w="med" len="med"/>
-                    </a:lnB>
-                    <a:solidFill>
-                      <a:srgbClr val="FFFFFF"/>
-                    </a:solidFill>
-                  </a:tcPr>
-                </a:tc>
-              </a:tr>
-              <a:tr h="384048">
-                <a:tc>
-                  <a:txBody>
-                    <a:bodyPr/>
-                    <a:lstStyle/>
-                    <a:p>
-                      <a:pPr algn="ctr" indent="0" marL="0">
-                        <a:buNone/>
-                      </a:pPr>
-                      <a:r>
-                        <a:rPr lang="en-US" sz="1200" b="1" dirty="0">
-                          <a:solidFill>
-                            <a:srgbClr val="1F2421"/>
-                          </a:solidFill>
-                        </a:rPr>
-                        <a:t>해외 판매</a:t>
-                      </a:r>
-                      <a:endParaRPr lang="en-US" sz="1200" dirty="0"/>
-                    </a:p>
-                  </a:txBody>
-                  <a:tcPr marL="91440" marR="91440" marT="36576" marB="36576" anchor="ctr">
-                    <a:lnL w="0" cap="flat" cmpd="sng" algn="ctr">
-                      <a:noFill/>
-                    </a:lnL>
-                    <a:lnR w="0" cap="flat" cmpd="sng" algn="ctr">
-                      <a:noFill/>
-                    </a:lnR>
-                    <a:lnT w="0" cap="flat" cmpd="sng" algn="ctr">
-                      <a:noFill/>
-                    </a:lnT>
-                    <a:lnB w="9525" cap="flat" cmpd="sng" algn="ctr">
-                      <a:solidFill>
-                        <a:srgbClr val="D9DED9"/>
-                      </a:solidFill>
-                      <a:prstDash val="solid"/>
-                      <a:round/>
-                      <a:headEnd type="none" w="med" len="med"/>
-                      <a:tailEnd type="none" w="med" len="med"/>
-                    </a:lnB>
-                    <a:solidFill>
-                      <a:srgbClr val="F2F4F2"/>
-                    </a:solidFill>
-                  </a:tcPr>
-                </a:tc>
-                <a:tc>
-                  <a:txBody>
-                    <a:bodyPr/>
-                    <a:lstStyle/>
-                    <a:p>
-                      <a:pPr algn="l" indent="0" marL="0">
-                        <a:buNone/>
-                      </a:pPr>
-                      <a:r>
-                        <a:rPr lang="en-US" sz="1200" dirty="0">
-                          <a:solidFill>
-                            <a:srgbClr val="1F2421"/>
-                          </a:solidFill>
-                        </a:rPr>
-                        <a:t>건조 나물 + 레시피 키트</a:t>
-                      </a:r>
-                      <a:endParaRPr lang="en-US" sz="1200" dirty="0"/>
-                    </a:p>
-                  </a:txBody>
-                  <a:tcPr marL="91440" marR="91440" marT="36576" marB="36576" anchor="ctr">
-                    <a:lnL w="0" cap="flat" cmpd="sng" algn="ctr">
-                      <a:noFill/>
-                    </a:lnL>
-                    <a:lnR w="0" cap="flat" cmpd="sng" algn="ctr">
-                      <a:noFill/>
-                    </a:lnR>
-                    <a:lnT w="0" cap="flat" cmpd="sng" algn="ctr">
-                      <a:noFill/>
-                    </a:lnT>
-                    <a:lnB w="9525" cap="flat" cmpd="sng" algn="ctr">
-                      <a:solidFill>
-                        <a:srgbClr val="D9DED9"/>
-                      </a:solidFill>
-                      <a:prstDash val="solid"/>
-                      <a:round/>
-                      <a:headEnd type="none" w="med" len="med"/>
-                      <a:tailEnd type="none" w="med" len="med"/>
-                    </a:lnB>
-                    <a:solidFill>
-                      <a:srgbClr val="FFFFFF"/>
-                    </a:solidFill>
-                  </a:tcPr>
-                </a:tc>
-              </a:tr>
             </a:tbl>
           </a:graphicData>
         </a:graphic>
@@ -5899,7 +5913,7 @@
                   <a:srgbClr val="C7D6CC"/>
                 </a:solidFill>
               </a:rPr>
-              <a:t>유료 주문 100건 · 배달 비교</a:t>
+              <a:t>유료 주문 100건 · 배달 비용 확인</a:t>
             </a:r>
             <a:endParaRPr lang="en-US" sz="1150" dirty="0"/>
           </a:p>
@@ -6290,7 +6304,7 @@
                 <a:gridCol w="4572000"/>
                 <a:gridCol w="1783080"/>
               </a:tblGrid>
-              <a:tr h="292608">
+              <a:tr h="274320">
                 <a:tc>
                   <a:txBody>
                     <a:bodyPr/>
@@ -6403,7 +6417,7 @@
                   </a:tcPr>
                 </a:tc>
               </a:tr>
-              <a:tr h="301752">
+              <a:tr h="274320">
                 <a:tc>
                   <a:txBody>
                     <a:bodyPr/>
@@ -6534,7 +6548,7 @@
                   </a:tcPr>
                 </a:tc>
               </a:tr>
-              <a:tr h="301752">
+              <a:tr h="274320">
                 <a:tc>
                   <a:txBody>
                     <a:bodyPr/>
@@ -6592,7 +6606,7 @@
                             <a:srgbClr val="1F2421"/>
                           </a:solidFill>
                         </a:rPr>
-                        <a:t>입점 300곳 × 월 100건 × 15,000원 × 12개월</a:t>
+                        <a:t>입점 300곳 × 월 100건(일반·명절 예약) × 15,000원 × 12개월</a:t>
                       </a:r>
                       <a:endParaRPr lang="en-US" sz="1100" dirty="0"/>
                     </a:p>
@@ -6665,7 +6679,7 @@
                   </a:tcPr>
                 </a:tc>
               </a:tr>
-              <a:tr h="301752">
+              <a:tr h="274320">
                 <a:tc>
                   <a:txBody>
                     <a:bodyPr/>
@@ -6723,7 +6737,7 @@
                             <a:srgbClr val="1F2421"/>
                           </a:solidFill>
                         </a:rPr>
-                        <a:t>54억 원 × 4% (일반·예약 주문)</a:t>
+                        <a:t>54억 원 × 4% (배달비 제외, 면제·할인 전 단순 산식)</a:t>
                       </a:r>
                       <a:endParaRPr lang="en-US" sz="1100" dirty="0"/>
                     </a:p>
@@ -6796,7 +6810,7 @@
                   </a:tcPr>
                 </a:tc>
               </a:tr>
-              <a:tr h="301752">
+              <a:tr h="274320">
                 <a:tc>
                   <a:txBody>
                     <a:bodyPr/>
@@ -6927,7 +6941,7 @@
                   </a:tcPr>
                 </a:tc>
               </a:tr>
-              <a:tr h="301752">
+              <a:tr h="274320">
                 <a:tc>
                   <a:txBody>
                     <a:bodyPr/>
@@ -6942,7 +6956,7 @@
                             <a:srgbClr val="1E4D3A"/>
                           </a:solidFill>
                         </a:rPr>
-                        <a:t>3년차 매출 (기본)</a:t>
+                        <a:t>3년차 매출 목표</a:t>
                       </a:r>
                       <a:endParaRPr lang="en-US" sz="1100" dirty="0"/>
                     </a:p>
@@ -6985,7 +6999,7 @@
                             <a:srgbClr val="1F2421"/>
                           </a:solidFill>
                         </a:rPr>
-                        <a:t>수수료 + 판매자 유료 서비스</a:t>
+                        <a:t>수수료 + 판매자 유료 서비스 (기본 수익원으로 계산한 목표)</a:t>
                       </a:r>
                       <a:endParaRPr lang="en-US" sz="1100" dirty="0"/>
                     </a:p>
@@ -7058,7 +7072,138 @@
                   </a:tcPr>
                 </a:tc>
               </a:tr>
-              <a:tr h="301752">
+              <a:tr h="274320">
+                <a:tc>
+                  <a:txBody>
+                    <a:bodyPr/>
+                    <a:lstStyle/>
+                    <a:p>
+                      <a:pPr algn="l" indent="0" marL="0">
+                        <a:buNone/>
+                      </a:pPr>
+                      <a:r>
+                        <a:rPr lang="en-US" sz="1100" b="1" dirty="0">
+                          <a:solidFill>
+                            <a:srgbClr val="1F2421"/>
+                          </a:solidFill>
+                        </a:rPr>
+                        <a:t>보수 시나리오</a:t>
+                      </a:r>
+                      <a:endParaRPr lang="en-US" sz="1100" dirty="0"/>
+                    </a:p>
+                  </a:txBody>
+                  <a:tcPr marL="91440" marR="91440" marT="18288" marB="18288" anchor="ctr">
+                    <a:lnL w="0" cap="flat" cmpd="sng" algn="ctr">
+                      <a:noFill/>
+                    </a:lnL>
+                    <a:lnR w="0" cap="flat" cmpd="sng" algn="ctr">
+                      <a:noFill/>
+                    </a:lnR>
+                    <a:lnT w="0" cap="flat" cmpd="sng" algn="ctr">
+                      <a:noFill/>
+                    </a:lnT>
+                    <a:lnB w="9525" cap="flat" cmpd="sng" algn="ctr">
+                      <a:solidFill>
+                        <a:srgbClr val="D9DED9"/>
+                      </a:solidFill>
+                      <a:prstDash val="solid"/>
+                      <a:round/>
+                      <a:headEnd type="none" w="med" len="med"/>
+                      <a:tailEnd type="none" w="med" len="med"/>
+                    </a:lnB>
+                    <a:solidFill>
+                      <a:srgbClr val="F2F4F2"/>
+                    </a:solidFill>
+                  </a:tcPr>
+                </a:tc>
+                <a:tc>
+                  <a:txBody>
+                    <a:bodyPr/>
+                    <a:lstStyle/>
+                    <a:p>
+                      <a:pPr algn="l" indent="0" marL="0">
+                        <a:buNone/>
+                      </a:pPr>
+                      <a:r>
+                        <a:rPr lang="en-US" sz="1100" dirty="0">
+                          <a:solidFill>
+                            <a:srgbClr val="1F2421"/>
+                          </a:solidFill>
+                        </a:rPr>
+                        <a:t>매장당 월 77건 → 거래액 41.4억 원 × 4% + 0.4억 원</a:t>
+                      </a:r>
+                      <a:endParaRPr lang="en-US" sz="1100" dirty="0"/>
+                    </a:p>
+                  </a:txBody>
+                  <a:tcPr marL="91440" marR="91440" marT="18288" marB="18288" anchor="ctr">
+                    <a:lnL w="0" cap="flat" cmpd="sng" algn="ctr">
+                      <a:noFill/>
+                    </a:lnL>
+                    <a:lnR w="0" cap="flat" cmpd="sng" algn="ctr">
+                      <a:noFill/>
+                    </a:lnR>
+                    <a:lnT w="0" cap="flat" cmpd="sng" algn="ctr">
+                      <a:noFill/>
+                    </a:lnT>
+                    <a:lnB w="9525" cap="flat" cmpd="sng" algn="ctr">
+                      <a:solidFill>
+                        <a:srgbClr val="D9DED9"/>
+                      </a:solidFill>
+                      <a:prstDash val="solid"/>
+                      <a:round/>
+                      <a:headEnd type="none" w="med" len="med"/>
+                      <a:tailEnd type="none" w="med" len="med"/>
+                    </a:lnB>
+                    <a:solidFill>
+                      <a:srgbClr val="FFFFFF"/>
+                    </a:solidFill>
+                  </a:tcPr>
+                </a:tc>
+                <a:tc>
+                  <a:txBody>
+                    <a:bodyPr/>
+                    <a:lstStyle/>
+                    <a:p>
+                      <a:pPr algn="r" indent="0" marL="0">
+                        <a:buNone/>
+                      </a:pPr>
+                      <a:r>
+                        <a:rPr lang="en-US" sz="1100" b="1" dirty="0">
+                          <a:solidFill>
+                            <a:srgbClr val="4A524D"/>
+                          </a:solidFill>
+                        </a:rPr>
+                        <a:t>약 2.1억 원</a:t>
+                      </a:r>
+                      <a:endParaRPr lang="en-US" sz="1100" dirty="0"/>
+                    </a:p>
+                  </a:txBody>
+                  <a:tcPr marL="91440" marR="91440" marT="18288" marB="18288" anchor="ctr">
+                    <a:lnL w="0" cap="flat" cmpd="sng" algn="ctr">
+                      <a:noFill/>
+                    </a:lnL>
+                    <a:lnR w="0" cap="flat" cmpd="sng" algn="ctr">
+                      <a:noFill/>
+                    </a:lnR>
+                    <a:lnT w="0" cap="flat" cmpd="sng" algn="ctr">
+                      <a:noFill/>
+                    </a:lnT>
+                    <a:lnB w="9525" cap="flat" cmpd="sng" algn="ctr">
+                      <a:solidFill>
+                        <a:srgbClr val="D9DED9"/>
+                      </a:solidFill>
+                      <a:prstDash val="solid"/>
+                      <a:round/>
+                      <a:headEnd type="none" w="med" len="med"/>
+                      <a:tailEnd type="none" w="med" len="med"/>
+                    </a:lnB>
+                    <a:solidFill>
+                      <a:srgbClr val="FFFFFF"/>
+                    </a:solidFill>
+                  </a:tcPr>
+                </a:tc>
+              </a:tr>
+              <a:tr h="274320">
                 <a:tc>
                   <a:txBody>
                     <a:bodyPr/>
@@ -7189,7 +7334,7 @@
                   </a:tcPr>
                 </a:tc>
               </a:tr>
-              <a:tr h="301752">
+              <a:tr h="274320">
                 <a:tc>
                   <a:txBody>
                     <a:bodyPr/>
@@ -7320,7 +7465,7 @@
                   </a:tcPr>
                 </a:tc>
               </a:tr>
-              <a:tr h="301752">
+              <a:tr h="274320">
                 <a:tc>
                   <a:txBody>
                     <a:bodyPr/>
@@ -7335,7 +7480,7 @@
                             <a:srgbClr val="1F2421"/>
                           </a:solidFill>
                         </a:rPr>
-                        <a:t>배달비 (고객 부담)</a:t>
+                        <a:t>배달비 (시험 요금)</a:t>
                       </a:r>
                       <a:endParaRPr lang="en-US" sz="1100" dirty="0"/>
                     </a:p>
@@ -7378,7 +7523,7 @@
                             <a:srgbClr val="1F2421"/>
                           </a:solidFill>
                         </a:rPr>
-                        <a:t>배달대행 비용으로 지급, 수익 아님 · 기본료 보도 사례 건당 4,000~4,900원</a:t>
+                        <a:t>마진 없이 연결(매출 제외) · 차액은 파일럿 예산 20만 원 한도 지원</a:t>
                       </a:r>
                       <a:endParaRPr lang="en-US" sz="1100" dirty="0"/>
                     </a:p>
@@ -7421,7 +7566,7 @@
                             <a:srgbClr val="4A524D"/>
                           </a:solidFill>
                         </a:rPr>
-                        <a:t>예정 3,500원/건</a:t>
+                        <a:t>3,500원/건</a:t>
                       </a:r>
                       <a:endParaRPr lang="en-US" sz="1100" dirty="0"/>
                     </a:p>
@@ -7451,7 +7596,7 @@
                   </a:tcPr>
                 </a:tc>
               </a:tr>
-              <a:tr h="301752">
+              <a:tr h="274320">
                 <a:tc>
                   <a:txBody>
                     <a:bodyPr/>
@@ -7616,7 +7761,7 @@
                   <a:srgbClr val="7A837D"/>
                 </a:solidFill>
               </a:rPr>
-              <a:t>주: LLM 호출비는 Claude API 가격표(2026.10, 1달러=1,400원) 기준 추정, 재시도·서버·검수 인건비 별도 / 유료 판매자 120곳·배달비는 가정, 묶음배달로 건당 원가를 배달비 이하로 맞추는 것이 파일럿 과제</a:t>
+              <a:t>주: LLM 호출비는 Claude API 가격표(2026.10, 1달러=1,400원) 기준, 재시도·서버·검수 별도 / 배달대행 기본료 보도 사례: 2024년 일부 업체 4,900~5,800원</a:t>
             </a:r>
             <a:endParaRPr lang="en-US" sz="900" dirty="0"/>
           </a:p>
@@ -8199,7 +8344,7 @@
                   </a:extLst>
                 </a:hlinkClick>
               </a:rPr>
-              <a:t>문화일보, 배달대행 건당 기본료 인상 보도 (2024.10 무렵)</a:t>
+              <a:t>문화일보 · 뉴데일리, 배달대행 기본료 인상 보도 (2024.10)</a:t>
             </a:r>
             <a:endParaRPr lang="en-US" sz="1050" dirty="0"/>
           </a:p>
@@ -8228,7 +8373,7 @@
                   </a:extLst>
                 </a:hlinkClick>
               </a:rPr>
-              <a:t>바이라인네트워크, 배민스토어 전통시장 서비스 (2024.01)</a:t>
+              <a:t>바이라인네트워크, 배민스토어 전통시장 합배송 (2024.01)</a:t>
             </a:r>
             <a:endParaRPr lang="en-US" sz="1050" dirty="0"/>
           </a:p>
@@ -10058,7 +10203,7 @@
         </p:nvSpPr>
         <p:spPr>
           <a:xfrm>
-            <a:off x="4206240" y="2651760"/>
+            <a:off x="4206240" y="2578608"/>
             <a:ext cx="4526280" cy="0"/>
           </a:xfrm>
           <a:prstGeom prst="line">
@@ -10081,7 +10226,7 @@
         </p:nvSpPr>
         <p:spPr>
           <a:xfrm>
-            <a:off x="3794760" y="2807208"/>
+            <a:off x="3794760" y="2660904"/>
             <a:ext cx="274320" cy="274320"/>
           </a:xfrm>
           <a:prstGeom prst="ellipse">
@@ -10106,7 +10251,7 @@
         </p:nvSpPr>
         <p:spPr>
           <a:xfrm>
-            <a:off x="3794760" y="2807208"/>
+            <a:off x="3794760" y="2660904"/>
             <a:ext cx="274320" cy="274320"/>
           </a:xfrm>
           <a:prstGeom prst="rect">
@@ -10142,7 +10287,7 @@
         </p:nvSpPr>
         <p:spPr>
           <a:xfrm>
-            <a:off x="4206240" y="2779776"/>
+            <a:off x="4206240" y="2633472"/>
             <a:ext cx="4526280" cy="310896"/>
           </a:xfrm>
           <a:prstGeom prst="rect">
@@ -10178,7 +10323,7 @@
         </p:nvSpPr>
         <p:spPr>
           <a:xfrm>
-            <a:off x="4206240" y="3108960"/>
+            <a:off x="4206240" y="2962656"/>
             <a:ext cx="4526280" cy="292608"/>
           </a:xfrm>
           <a:prstGeom prst="rect">
@@ -10214,7 +10359,7 @@
         </p:nvSpPr>
         <p:spPr>
           <a:xfrm>
-            <a:off x="4206240" y="3511296"/>
+            <a:off x="4206240" y="3291840"/>
             <a:ext cx="4526280" cy="0"/>
           </a:xfrm>
           <a:prstGeom prst="line">
@@ -10237,7 +10382,7 @@
         </p:nvSpPr>
         <p:spPr>
           <a:xfrm>
-            <a:off x="3794760" y="3666744"/>
+            <a:off x="3794760" y="3374136"/>
             <a:ext cx="274320" cy="274320"/>
           </a:xfrm>
           <a:prstGeom prst="ellipse">
@@ -10262,7 +10407,7 @@
         </p:nvSpPr>
         <p:spPr>
           <a:xfrm>
-            <a:off x="3794760" y="3666744"/>
+            <a:off x="3794760" y="3374136"/>
             <a:ext cx="274320" cy="274320"/>
           </a:xfrm>
           <a:prstGeom prst="rect">
@@ -10298,7 +10443,7 @@
         </p:nvSpPr>
         <p:spPr>
           <a:xfrm>
-            <a:off x="4206240" y="3639312"/>
+            <a:off x="4206240" y="3346704"/>
             <a:ext cx="4526280" cy="310896"/>
           </a:xfrm>
           <a:prstGeom prst="rect">
@@ -10334,7 +10479,7 @@
         </p:nvSpPr>
         <p:spPr>
           <a:xfrm>
-            <a:off x="4206240" y="3968496"/>
+            <a:off x="4206240" y="3675888"/>
             <a:ext cx="4526280" cy="292608"/>
           </a:xfrm>
           <a:prstGeom prst="rect">
@@ -10364,7 +10509,79 @@
       </p:sp>
       <p:sp>
         <p:nvSpPr>
-          <p:cNvPr id="30" name="source note"/>
+          <p:cNvPr id="30" name="need band"/>
+          <p:cNvSpPr/>
+          <p:nvPr/>
+        </p:nvSpPr>
+        <p:spPr>
+          <a:xfrm>
+            <a:off x="3794760" y="4005072"/>
+            <a:ext cx="4937760" cy="384048"/>
+          </a:xfrm>
+          <a:prstGeom prst="rect">
+            <a:avLst/>
+          </a:prstGeom>
+          <a:solidFill>
+            <a:srgbClr val="E6F0EA"/>
+          </a:solidFill>
+          <a:ln w="12700">
+            <a:solidFill>
+              <a:srgbClr val="E6F0EA"/>
+            </a:solidFill>
+            <a:prstDash val="solid"/>
+          </a:ln>
+        </p:spPr>
+      </p:sp>
+      <p:sp>
+        <p:nvSpPr>
+          <p:cNvPr id="31" name="need text"/>
+          <p:cNvSpPr txBox="1"/>
+          <p:nvPr/>
+        </p:nvSpPr>
+        <p:spPr>
+          <a:xfrm>
+            <a:off x="3913632" y="4005072"/>
+            <a:ext cx="4754880" cy="384048"/>
+          </a:xfrm>
+          <a:prstGeom prst="rect">
+            <a:avLst/>
+          </a:prstGeom>
+          <a:noFill/>
+          <a:ln/>
+        </p:spPr>
+        <p:txBody>
+          <a:bodyPr wrap="square" lIns="0" tIns="0" rIns="0" bIns="0" rtlCol="0" anchor="ctr"/>
+          <a:lstStyle/>
+          <a:p>
+            <a:pPr indent="0" marL="0">
+              <a:buNone/>
+            </a:pPr>
+            <a:r>
+              <a:rPr lang="en-US" sz="1150" b="1" dirty="0">
+                <a:solidFill>
+                  <a:srgbClr val="1E4D3A"/>
+                </a:solidFill>
+              </a:rPr>
+              <a:t>필요  </a:t>
+            </a:r>
+            <a:pPr indent="0" marL="0">
+              <a:buNone/>
+            </a:pPr>
+            <a:r>
+              <a:rPr lang="en-US" sz="1150" dirty="0">
+                <a:solidFill>
+                  <a:srgbClr val="1F2421"/>
+                </a:solidFill>
+              </a:rPr>
+              <a:t>적은 입력으로 상품 등록 · 손질 서비스 홍보 · 예약 주문 통로</a:t>
+            </a:r>
+            <a:endParaRPr lang="en-US" sz="1150" dirty="0"/>
+          </a:p>
+        </p:txBody>
+      </p:sp>
+      <p:sp>
+        <p:nvSpPr>
+          <p:cNvPr id="32" name="source note"/>
           <p:cNvSpPr txBox="1"/>
           <p:nvPr/>
         </p:nvSpPr>
@@ -10955,7 +11172,7 @@
                   <a:srgbClr val="1F2421"/>
                 </a:solidFill>
               </a:rPr>
-              <a:t>가게 픽업(무료) 또는 저녁 묶음배달(배차는 나물로)</a:t>
+              <a:t>가게 픽업(무료) 또는 저녁 배달(배달대행 연결)</a:t>
             </a:r>
             <a:endParaRPr lang="en-US" sz="1200" dirty="0"/>
           </a:p>
@@ -15837,7 +16054,7 @@
                   <a:schemeClr val="tx1"/>
                 </a:solidFill>
               </a:rPr>
-              <a:t>중개 수수료를 기본 수익원으로 하고 판매자 유료 서비스·제휴 광고로 확대, 배달비는 고객 부담</a:t>
+              <a:t>중개 수수료를 기본 수익원으로 하고 판매자 유료 서비스·제휴 광고로 확대, 배달은 마진 없이 연결</a:t>
             </a:r>
             <a:endParaRPr lang="en-US" sz="1300" dirty="0"/>
           </a:p>
@@ -15987,7 +16204,7 @@
                   <a:srgbClr val="FFFFFF"/>
                 </a:solidFill>
               </a:rPr>
-              <a:t>주문 · 배차 · 정산</a:t>
+              <a:t>주문 · 배달 연결 · 정산</a:t>
             </a:r>
             <a:endParaRPr lang="en-US" sz="1500" dirty="0"/>
           </a:p>
@@ -16331,9 +16548,9 @@
             <a:tbl>
               <a:tblPr/>
               <a:tblGrid>
+                <a:gridCol w="1737360"/>
                 <a:gridCol w="1828800"/>
-                <a:gridCol w="2103120"/>
-                <a:gridCol w="4389120"/>
+                <a:gridCol w="4754880"/>
               </a:tblGrid>
               <a:tr h="310896">
                 <a:tc>
@@ -16506,7 +16723,7 @@
                             <a:srgbClr val="1F2421"/>
                           </a:solidFill>
                         </a:rPr>
-                        <a:t>주문 금액의 4%</a:t>
+                        <a:t>상품·손질 금액의 4%</a:t>
                       </a:r>
                       <a:endParaRPr lang="en-US" sz="1200" dirty="0"/>
                     </a:p>
@@ -16549,7 +16766,7 @@
                             <a:srgbClr val="1F2421"/>
                           </a:solidFill>
                         </a:rPr>
-                        <a:t>일반·예약 주문 공통 · 전통시장 점포는 첫 6개월 0%</a:t>
+                        <a:t>배달비 제외 · 일반·예약 공통 · 전통시장 점포 첫 6개월 0%</a:t>
                       </a:r>
                       <a:endParaRPr lang="en-US" sz="1200" dirty="0"/>
                     </a:p>
@@ -16637,7 +16854,7 @@
                             <a:srgbClr val="1F2421"/>
                           </a:solidFill>
                         </a:rPr>
-                        <a:t>고객 부담 3,500원</a:t>
+                        <a:t>시험 요금 3,500원</a:t>
                       </a:r>
                       <a:endParaRPr lang="en-US" sz="1200" dirty="0"/>
                     </a:p>
@@ -16680,7 +16897,7 @@
                             <a:srgbClr val="1F2421"/>
                           </a:solidFill>
                         </a:rPr>
-                        <a:t>저녁 배달 선택 시 · 배달대행 비용으로 지급, 수익 아님</a:t>
+                        <a:t>매출 제외(마진 없음) · 차액은 파일럿 예산 한도 내 부담</a:t>
                       </a:r>
                       <a:endParaRPr lang="en-US" sz="1200" dirty="0"/>
                     </a:p>

</xml_diff>

<commit_message>
namul: v4.4 — Codex 4차 리뷰 반영 (제출 전 최종)
- A14 인용(제출 전 필수): 확인된 뉴데일리(2024.10.07)의 '5,400~5,800원 인상
  예정' 보도로 좁힘. 부록 1 각주는 '배달대행 요금은 견적으로 확인', 부록 2의
  10번은 뉴데일리 문구·링크로 교체, Q&A에서는 기사 숫자를 뺌. 04 A14는
  문화일보를 '원문 미확인 참고'로 구분, 01 §2.5·3.6 문구도 맞춤
- 선택 개선: 3·9·10번과 부록 1의 반복 문구 축소, '매장당 월 약 77건',
  '지원 잔액이 부족하면', '배달비에는 별도 이익을 붙이지 않음', 배달 Q&A 세 문장,
  주문 전 판매자 카드에 '예시 주문' 표시
- 03 앞부분에 녹화가 10분에 가까울 때 줄여도 되는 문장 네 곳
- 09·README 갱신, 대본 추정 8:52, AI 음성 초안 8:55

Co-Authored-By: Claude Opus 5.5 <noreply@anthropic.com>
Claude-Session: https://claude.ai/code/session_01WM2pJ2E8tXi8UPjx1jXtrm
</commit_message>
<xml_diff>
--- a/namul-platform/02_발표자료_나물로.pptx
+++ b/namul-platform/02_발표자료_나물로.pptx
@@ -120,43 +120,43 @@
   <p:extLst>
     <p:ext uri="{521415D9-36F7-43E2-AB2F-B90AF26B5E84}">
       <p14:sectionLst xmlns:p14="http://schemas.microsoft.com/office/powerpoint/2010/main">
-        <p14:section name="표지" id="{a5990608-a50f-8baa-bd7d-fe7a88b827e0}">
+        <p14:section name="표지" id="{6e9ea187-e8ac-b6c2-5500-2d99528f1504}">
           <p14:sldIdLst>
             <p14:sldId id="256"/>
           </p14:sldIdLst>
         </p14:section>
-        <p14:section name="Problem" id="{5c653a87-0794-ac74-45de-831bdf52acf1}">
+        <p14:section name="Problem" id="{2c7b6165-a224-346c-ec93-1829fd1f8030}">
           <p14:sldIdLst>
             <p14:sldId id="257"/>
             <p14:sldId id="258"/>
           </p14:sldIdLst>
         </p14:section>
-        <p14:section name="Solution" id="{a2d5156f-8ae3-ba52-cc25-2dbc33c4f3f6}">
+        <p14:section name="Solution" id="{71c394a7-7919-e75f-44aa-efb82b01a6f6}">
           <p14:sldIdLst>
             <p14:sldId id="259"/>
             <p14:sldId id="260"/>
             <p14:sldId id="261"/>
           </p14:sldIdLst>
         </p14:section>
-        <p14:section name="Business" id="{14fd5885-3df6-220b-7449-e54ab6d58036}">
+        <p14:section name="Business" id="{2b628a76-e245-f65d-5e3c-9431463e00a7}">
           <p14:sldIdLst>
             <p14:sldId id="262"/>
             <p14:sldId id="263"/>
             <p14:sldId id="264"/>
           </p14:sldIdLst>
         </p14:section>
-        <p14:section name="Vision" id="{30587351-1092-3918-c8d5-e5d660851a4a}">
+        <p14:section name="Vision" id="{5f3be871-0c0e-3f85-77e0-cbd7d74c1dec}">
           <p14:sldIdLst>
             <p14:sldId id="265"/>
             <p14:sldId id="266"/>
           </p14:sldIdLst>
         </p14:section>
-        <p14:section name="마무리" id="{cdf8e19d-ca1f-f5e7-0c73-5d0c20c25b45}">
+        <p14:section name="마무리" id="{2592c2c8-25d0-b3a7-274f-8818d1dd313d}">
           <p14:sldIdLst>
             <p14:sldId id="267"/>
           </p14:sldIdLst>
         </p14:section>
-        <p14:section name="부록" id="{c60a6c30-da19-3276-d626-a6a1e5f9f0d1}">
+        <p14:section name="부록" id="{addcc571-d1ab-dc07-6783-d309886e4df6}">
           <p14:sldIdLst>
             <p14:sldId id="268"/>
             <p14:sldId id="269"/>
@@ -947,7 +947,7 @@
           <a:p>
             <a:r>
               <a:rPr lang="en-US" dirty="0"/>
-              <a:t>[7:01–7:48] 사업화는 세 단계로 진행합니다. 1단계는 올겨울, 주거 단지 근처 전통시장 한 곳의 점포 두세 곳과 함께하는 3개월 파일럿입니다. 자기자본 300만 원으로 시작합니다. 여기서 유료 주문 100건을 목표로, 30일 재구매율, 손질 옵션 선택률, 배달 선택률과 배달 한 건당 비용, 주문당 운영 시간을 측정하겠습니다. 결과가 기대에 못 미치면 타깃 고객이나 가격을 바꿔 다시 검증하겠습니다. 2단계는 예비창업패키지 같은 정부 지원사업으로 웹앱을 정식 출시하고 명절 예약을 열며 입점 매장을 30곳으로 늘리는 것이고, 3단계는 시드 투자를 받아 수도권으로 확장하는 것입니다.</a:t>
+              <a:t>[6:58–7:45] 사업화는 세 단계로 진행합니다. 1단계는 올겨울, 주거 단지 근처 전통시장 한 곳의 점포 두세 곳과 함께하는 3개월 파일럿입니다. 자기자본 300만 원으로 시작합니다. 여기서 유료 주문 100건을 목표로, 30일 재구매율, 손질 옵션 선택률, 배달 선택률과 배달 한 건당 비용, 주문당 운영 시간을 측정하겠습니다. 결과가 기대에 못 미치면 타깃 고객이나 가격을 바꿔 다시 검증하겠습니다. 2단계는 예비창업패키지 같은 정부 지원사업으로 웹앱을 정식 출시하고 명절 예약을 열며 입점 매장을 30곳으로 늘리는 것이고, 3단계는 시드 투자를 받아 수도권으로 확장하는 것입니다.</a:t>
             </a:r>
             <a:endParaRPr lang="en-US" dirty="0"/>
           </a:p>
@@ -1035,7 +1035,7 @@
           <a:p>
             <a:r>
               <a:rPr lang="en-US" dirty="0"/>
-              <a:t>[7:48–8:32] 3년 차 목표는 거래액 54억 원, 매출 약 2.6억 원입니다. 매출 목표는 주문 수수료와 판매자 유료 서비스로 계산했고, 지자체 사업이나 제휴 매출은 계약을 확보한 뒤 반영하겠습니다. 보수적으로 매장당 월 77건으로 잡으면 매출은 약 2.1억 원이고, 숫자는 모두 가정이라 파일럿이 끝나면 실제 데이터로 다시 계산하겠습니다. 확장은 첫 시장에서 재구매와 주문당 운영비를 확인한 뒤, 인접 시장과 제철 농산물 전체로 넓혀 가겠습니다. 이를 통해 전통시장의 매출을 늘리고, 아이들이 채소 반찬을 더 쉽게 먹도록 돕는 것이 목표입니다.</a:t>
+              <a:t>[7:45–8:30] 3년 차 목표는 거래액 54억 원, 매출 약 2.6억 원입니다. 매출 목표는 주문 수수료와 판매자 유료 서비스로 계산했고, 지자체 사업이나 제휴 매출은 계약을 확보한 뒤 반영하겠습니다. 보수적으로 매장당 월 약 77건으로 잡으면 매출은 약 2.1억 원이고, 숫자는 모두 가정이라 파일럿이 끝나면 실제 데이터로 다시 계산하겠습니다. 확장은 첫 시장에서 재구매와 주문당 운영비를 확인한 뒤, 인접 시장과 제철 농산물 전체로 넓혀 가겠습니다. 이를 통해 전통시장의 매출을 늘리고, 아이들이 채소 반찬을 더 쉽게 먹도록 돕는 것이 목표입니다.</a:t>
             </a:r>
             <a:endParaRPr lang="en-US" dirty="0"/>
           </a:p>
@@ -1123,7 +1123,7 @@
           <a:p>
             <a:r>
               <a:rPr lang="en-US" dirty="0"/>
-              <a:t>[8:32–8:54] 정리하겠습니다. 나물로는 바쁜 맞벌이 가정에는 레시피와 동네 매장 픽업, 저녁 배달을, 전통시장 판매자에게는 온라인 판매 채널을 제공하는 서비스입니다. 먼저 시장 한 곳에서 사람들이 실제로 주문하고 다시 찾아오는지 확인해 보겠습니다. 들어 주셔서 감사합니다.</a:t>
+              <a:t>[8:30–8:52] 정리하겠습니다. 나물로는 바쁜 맞벌이 가정에는 레시피와 동네 매장 픽업, 저녁 배달을, 전통시장 판매자에게는 온라인 판매 채널을 제공하는 서비스입니다. 먼저 시장 한 곳에서 사람들이 실제로 주문하고 다시 찾아오는지 확인해 보겠습니다. 들어 주셔서 감사합니다.</a:t>
             </a:r>
             <a:endParaRPr lang="en-US" dirty="0"/>
           </a:p>
@@ -1475,7 +1475,7 @@
           <a:p>
             <a:r>
               <a:rPr lang="en-US" dirty="0"/>
-              <a:t>[1:19–2:14] 다음은 판매자 쪽입니다. 전국 전통시장은 약 1,400곳, 연매출은 28.7조 원 규모입니다. 배민 전통시장 장보기에 입점한 점포의 매출이 1년 사이 196% 늘었다는 보도를 보면, 시장 상품을 온라인으로 사려는 수요는 있다고 판단했습니다. 다만 상인이 상품을 올리고 주문까지 직접 관리하려면 일이 꽤 늘어날 것으로 봤습니다. 손질해서 팔면 값을 더 받을 수 있는데도 이를 알릴 방법이 마땅치 않고, 제철에는 물량이 몰려 재고 부담도 클 것으로 예상합니다. 그래서 판매자에게는 적은 입력으로 상품을 올리고, 손질 서비스를 알리고, 미리 주문을 받을 수 있는 통로가 필요하다고 봤습니다. 이 부분은 아직 가설이라서, 시장 상인 인터뷰로 실제 부담을 확인하려고 합니다.</a:t>
+              <a:t>[1:19–2:12] 다음은 판매자 쪽입니다. 전국 전통시장은 약 1,400곳, 연매출은 28.7조 원 규모입니다. 배민 전통시장 장보기에 입점한 점포의 매출이 1년 사이 196% 늘었다는 보도를 보면, 시장 상품을 온라인으로 사려는 수요는 있다고 판단했습니다. 다만 상인이 상품을 올리고 주문까지 직접 관리하려면 일이 꽤 늘어날 것으로 봤습니다. 손질해서 팔면 값을 더 받을 수 있는데도 이를 알릴 방법이 마땅치 않고, 제철에는 물량이 몰려 재고 부담도 클 것으로 예상합니다. 그래서 판매자에게는 상품을 쉽게 올리고 손질 주문을 미리 받을 수 있는 통로가 필요하다고 봤습니다. 이 부분은 아직 가설이라서, 시장 상인 인터뷰로 실제 부담을 확인하려고 합니다.</a:t>
             </a:r>
             <a:endParaRPr lang="en-US" dirty="0"/>
           </a:p>
@@ -1563,7 +1563,7 @@
           <a:p>
             <a:r>
               <a:rPr lang="en-US" dirty="0"/>
-              <a:t>[2:14–3:11] 그래서 나물로는 세 단계로 서비스를 제공합니다. 첫째, 제철 나물 정보와 손질법, 레시피를 보여 주고, 아이가 잘 먹는 메뉴를 따로 추천합니다. 둘째, 레시피 재료 가운데 집에 없는 것만 골라 장바구니에 담습니다. 셋째, 반경 3km 안의 전통시장, 로컬푸드 매장, 반찬가게 중 한 곳을 고르고, 가게에서 찾아갈지 저녁에 배달받을지 정합니다. 배달을 고르면 가게에서 상품을 준비하고, 나물로가 배달대행에 배달을 요청합니다. 손질이나 데침을 원하면 매장에서 추가 요금을 받고 처리해 주고, 설 차례 나물처럼 주문이 몰리는 날은 미리 예약을 받습니다. 정리하면 고객은 메뉴 추천과 손질 옵션, 저녁 배달로 준비 시간을 줄이고, 판매자는 메시지 상품 등록과 예약 주문으로 판매를 미리 준비할 수 있습니다.</a:t>
+              <a:t>[2:12–3:09] 그래서 나물로는 세 단계로 서비스를 제공합니다. 첫째, 제철 나물 정보와 손질법, 레시피를 보여 주고, 아이가 잘 먹는 메뉴를 따로 추천합니다. 둘째, 레시피 재료 가운데 집에 없는 것만 골라 장바구니에 담습니다. 셋째, 반경 3km 안의 전통시장, 로컬푸드 매장, 반찬가게 중 한 곳을 고르고, 가게에서 찾아갈지 저녁에 배달받을지 정합니다. 배달을 고르면 가게에서 상품을 준비하고, 나물로가 배달대행에 배달을 요청합니다. 손질이나 데침을 원하면 매장에서 추가 요금을 받고 처리해 주고, 설 차례 나물처럼 주문이 몰리는 날은 미리 예약을 받습니다. 정리하면 고객은 메뉴 추천과 손질 옵션, 저녁 배달로 준비 시간을 줄이고, 판매자는 메시지 상품 등록과 예약 주문으로 판매를 미리 준비할 수 있습니다.</a:t>
             </a:r>
             <a:endParaRPr lang="en-US" dirty="0"/>
           </a:p>
@@ -1651,7 +1651,7 @@
           <a:p>
             <a:r>
               <a:rPr lang="en-US" dirty="0"/>
-              <a:t>[3:11–4:03] AI는 세 가지 업무에 적용하려고 합니다. 첫째는 고객용 레시피 추천입니다. 아이 나이나 집에 있는 재료를 입력하면, 근처 매장 재고로 만들 수 있는 반찬을 추천합니다. 둘째는 판매자용 상품 등록입니다. 사장님이 평소처럼 참나물 스무 단, 한 단 3,500원이라고 메시지를 보내면, AI가 품목과 수량, 가격으로 정리하고, 사장님이 확인을 눌러야 앱에 올라갑니다. 셋째는 발주량 추천과 마감 할인인데, 이 기능은 주문 데이터가 쌓인 뒤에 도입할 계획입니다. 앞의 두 기능은 시연 화면까지 만들어 두었고, 화면의 응답과 매장, 가격은 예시 데이터입니다. 또 안전을 위해 AI가 야생에서 캔 식물의 식용 여부는 판단하지 않도록 했습니다.</a:t>
+              <a:t>[3:09–4:01] AI는 세 가지 업무에 적용하려고 합니다. 첫째는 고객용 레시피 추천입니다. 아이 나이나 집에 있는 재료를 입력하면, 근처 매장 재고로 만들 수 있는 반찬을 추천합니다. 둘째는 판매자용 상품 등록입니다. 사장님이 평소처럼 참나물 스무 단, 한 단 3,500원이라고 메시지를 보내면, AI가 품목과 수량, 가격으로 정리하고, 사장님이 확인을 눌러야 앱에 올라갑니다. 셋째는 발주량 추천과 마감 할인인데, 이 기능은 주문 데이터가 쌓인 뒤에 도입할 계획입니다. 앞의 두 기능은 시연 화면까지 만들어 두었고, 화면의 응답과 매장, 가격은 예시 데이터입니다. 또 안전을 위해 AI가 야생에서 캔 식물의 식용 여부는 판단하지 않도록 했습니다.</a:t>
             </a:r>
             <a:endParaRPr lang="en-US" dirty="0"/>
           </a:p>
@@ -1739,7 +1739,7 @@
           <a:p>
             <a:r>
               <a:rPr lang="en-US" dirty="0"/>
-              <a:t>[4:03–4:44] 웹 프로토타입으로 사용 흐름을 보여 드리겠습니다. 맞벌이 부모가 다섯 살 아이와 먹을 순한 반찬을 물으면, 추천 메뉴 세 가지가 나옵니다. 참나물 레시피를 보고 재료를 담은 뒤, 600미터 떨어진 시장 가게에서 손질 옵션을 고릅니다. 받는 방법은 가게 픽업과 저녁 배달 중에 고를 수 있는데, 여기서는 저녁 6시 픽업을 골랐습니다. 판매자 화면에서는 들어온 주문을 확인하고 접수합니다. 시연 속 AI 응답과 주문 데이터는 예시이고, 실제 결제와 배달 연동은 파일럿에서 검증하겠습니다.</a:t>
+              <a:t>[4:01–4:42] 웹 프로토타입으로 사용 흐름을 보여 드리겠습니다. 맞벌이 부모가 다섯 살 아이와 먹을 순한 반찬을 물으면, 추천 메뉴 세 가지가 나옵니다. 참나물 레시피를 보고 재료를 담은 뒤, 600미터 떨어진 시장 가게에서 손질 옵션을 고릅니다. 받는 방법은 가게 픽업과 저녁 배달 중에 고를 수 있는데, 여기서는 저녁 6시 픽업을 골랐습니다. 판매자 화면에서는 들어온 주문을 확인하고 접수합니다. 시연 속 AI 응답과 주문 데이터는 예시이고, 실제 결제와 배달 연동은 파일럿에서 검증하겠습니다.</a:t>
             </a:r>
             <a:endParaRPr lang="en-US" dirty="0"/>
           </a:p>
@@ -1827,7 +1827,7 @@
           <a:p>
             <a:r>
               <a:rPr lang="en-US" dirty="0"/>
-              <a:t>[4:44–5:28] 다음은 시장 규모입니다. 전통시장 전체 매출 28.7조 원에서 수도권 비중 40%와 채소, 나물류 비중 15%를 가정해, 1차 목표 시장을 약 1.7조 원으로 잡았습니다. 온라인 식품 거래와는 겹치는 부분이 있어서, 전통시장 매출만 기준으로 삼았습니다. 수도권과 품목 비중은 공개 통계로 보완하고, 파일럿에서는 참여 점포의 나물 매출과 주문 가능성을 확인하겠습니다. 3년 차 목표 거래액은 입점 매장 300곳이 일반 주문과 명절 예약을 합쳐 한 달에 100건씩, 평균 1만 5천 원 주문을 받는다고 가정해 54억 원으로 정했습니다.</a:t>
+              <a:t>[4:42–5:26] 다음은 시장 규모입니다. 전통시장 전체 매출 28.7조 원에서 수도권 비중 40%와 채소, 나물류 비중 15%를 가정해, 1차 목표 시장을 약 1.7조 원으로 잡았습니다. 온라인 식품 거래와는 겹치는 부분이 있어서, 전통시장 매출만 기준으로 삼았습니다. 수도권과 품목 비중은 공개 통계로 보완하고, 파일럿에서는 참여 점포의 나물 매출과 주문 가능성을 확인하겠습니다. 3년 차 목표 거래액은 입점 매장 300곳이 일반 주문과 명절 예약을 합쳐 한 달에 100건씩, 평균 1만 5천 원 주문을 받는다고 가정해 54억 원으로 정했습니다.</a:t>
             </a:r>
             <a:endParaRPr lang="en-US" dirty="0"/>
           </a:p>
@@ -1915,7 +1915,7 @@
           <a:p>
             <a:r>
               <a:rPr lang="en-US" dirty="0"/>
-              <a:t>[5:28–6:07] 경쟁 서비스를 보면, 쿠팡과 컬리는 전국 배송, 레시피 앱과 유튜브는 콘텐츠에 강하고, 배민과 네이버는 동네 가게 주문과 판매자 도구를 갖추고 있습니다. 나물로는 나물 요리를 고른 사람이 필요한 재료를 동네에서 손질까지 받아 살 수 있도록 만드는 데 집중했습니다. 손질과 데침 옵션은 판매자에게는 추가 매출이 되고, 고객에게는 조리 시간을 줄여 줍니다. 큰 플랫폼과 정면으로 경쟁하기보다, 상인들이 함께 쓸 수 있는 나물 전문 판매 채널로 자리 잡는 것이 목표입니다.</a:t>
+              <a:t>[5:26–6:05] 경쟁 서비스를 보면, 쿠팡과 컬리는 전국 배송, 레시피 앱과 유튜브는 콘텐츠에 강하고, 배민과 네이버는 동네 가게 주문과 판매자 도구를 갖추고 있습니다. 나물로는 나물 요리를 고른 사람이 필요한 재료를 동네에서 손질까지 받아 살 수 있도록 만드는 데 집중했습니다. 손질과 데침 옵션은 판매자에게는 추가 매출이 되고, 고객에게는 조리 시간을 줄여 줍니다. 큰 플랫폼과 정면으로 경쟁하기보다, 상인들이 함께 쓸 수 있는 나물 전문 판매 채널로 자리 잡는 것이 목표입니다.</a:t>
             </a:r>
             <a:endParaRPr lang="en-US" dirty="0"/>
           </a:p>
@@ -2003,7 +2003,7 @@
           <a:p>
             <a:r>
               <a:rPr lang="en-US" dirty="0"/>
-              <a:t>[6:07–7:01] 수익 모델은 세 가지입니다. 요금은 모두 예정안이고, 파일럿에서 검증할 계획입니다. 기본은 상품과 손질 금액의 4%를 받는 중개 수수료이고, 판매자가 선택하는 월 2만 9천 원의 유료 서비스와 제휴 광고를 더합니다. 배달은 별도 마진 없이 연결할 계획이라, 배달비는 매출 목표에서 제외했습니다. 배달비 3,500원은 시험 요금이고, 보도된 일부 배달대행 기본료는 이보다 높아서, 차액은 파일럿 예산 안에서 한도를 정해 부담하겠습니다. 초기에는 개별 주문과 명절 예약에 집중하고, 정기구독은 반복 구매 수요를 확인한 뒤 검토하겠습니다. 판매자 부담은 월 100건 매장 기준 거래액의 약 6%이고, 전통시장 점포는 첫 6개월 수수료를 받지 않겠습니다.</a:t>
+              <a:t>[6:05–6:58] 수익 모델은 세 가지입니다. 요금은 모두 예정안이고, 파일럿에서 검증할 계획입니다. 기본은 상품과 손질 금액의 4%를 받는 중개 수수료이고, 판매자가 선택하는 월 2만 9천 원의 유료 서비스와 제휴 광고를 더합니다. 배달비에는 별도 이익을 붙이지 않을 계획이라, 매출 목표에서 제외했습니다. 배달비 3,500원은 시험 요금이고, 보도된 일부 배달대행 기본료는 이보다 높아서, 차액은 파일럿 예산 안에서 한도를 정해 부담하겠습니다. 초기에는 개별 주문과 명절 예약에 집중하고, 정기구독은 반복 구매 수요를 확인한 뒤 검토하겠습니다. 판매자 부담은 월 100건 매장 기준 거래액의 약 6%이고, 전통시장 점포는 첫 6개월 수수료를 받지 않겠습니다.</a:t>
             </a:r>
             <a:endParaRPr lang="en-US" dirty="0"/>
           </a:p>
@@ -3969,7 +3969,7 @@
                             <a:srgbClr val="1F2421"/>
                           </a:solidFill>
                         </a:rPr>
-                        <a:t>웹 프로토타입 + 수동 운영</a:t>
+                        <a:t>웹 프로토타입</a:t>
                       </a:r>
                       <a:endParaRPr lang="en-US" sz="1200" dirty="0"/>
                     </a:p>
@@ -3983,7 +3983,7 @@
                             <a:srgbClr val="1F2421"/>
                           </a:solidFill>
                         </a:rPr>
-                        <a:t>(배달은 단지 한정 시험)</a:t>
+                        <a:t>수동 운영, 배달은 단지 한정</a:t>
                       </a:r>
                       <a:endParaRPr lang="en-US" sz="1200" dirty="0"/>
                     </a:p>
@@ -4185,7 +4185,7 @@
                             <a:srgbClr val="1F2421"/>
                           </a:solidFill>
                         </a:rPr>
-                        <a:t>(배달 차액 20만 원 한도)</a:t>
+                        <a:t>배달 지원 최대 20만 원</a:t>
                       </a:r>
                       <a:endParaRPr lang="en-US" sz="1200" dirty="0"/>
                     </a:p>
@@ -4923,7 +4923,7 @@
                   <a:srgbClr val="1F2421"/>
                 </a:solidFill>
               </a:rPr>
-              <a:t>보수 시나리오(매장당 월 77건) 약 2.1억 원</a:t>
+              <a:t>보수 시나리오(매장당 월 약 77건) 약 2.1억 원</a:t>
             </a:r>
             <a:endParaRPr lang="en-US" sz="1200" dirty="0"/>
           </a:p>
@@ -6737,7 +6737,7 @@
                             <a:srgbClr val="1F2421"/>
                           </a:solidFill>
                         </a:rPr>
-                        <a:t>54억 원 × 4% (배달비 제외, 면제·할인 전 단순 산식)</a:t>
+                        <a:t>54억 원 × 4% (배달비 제외, 면제·할인 전)</a:t>
                       </a:r>
                       <a:endParaRPr lang="en-US" sz="1100" dirty="0"/>
                     </a:p>
@@ -6999,7 +6999,7 @@
                             <a:srgbClr val="1F2421"/>
                           </a:solidFill>
                         </a:rPr>
-                        <a:t>수수료 + 판매자 유료 서비스 (기본 수익원으로 계산한 목표)</a:t>
+                        <a:t>수수료 + 판매자 유료 서비스</a:t>
                       </a:r>
                       <a:endParaRPr lang="en-US" sz="1100" dirty="0"/>
                     </a:p>
@@ -7130,7 +7130,7 @@
                             <a:srgbClr val="1F2421"/>
                           </a:solidFill>
                         </a:rPr>
-                        <a:t>매장당 월 77건 → 거래액 41.4억 원 × 4% + 0.4억 원</a:t>
+                        <a:t>거래액 41.4억 원(매장당 월 약 77건) × 4% + 판매자 서비스</a:t>
                       </a:r>
                       <a:endParaRPr lang="en-US" sz="1100" dirty="0"/>
                     </a:p>
@@ -7523,7 +7523,7 @@
                             <a:srgbClr val="1F2421"/>
                           </a:solidFill>
                         </a:rPr>
-                        <a:t>마진 없이 연결(매출 제외) · 차액은 파일럿 예산 20만 원 한도 지원</a:t>
+                        <a:t>매출 목표 제외 / 차액 최대 20만 원 지원</a:t>
                       </a:r>
                       <a:endParaRPr lang="en-US" sz="1100" dirty="0"/>
                     </a:p>
@@ -7761,7 +7761,7 @@
                   <a:srgbClr val="7A837D"/>
                 </a:solidFill>
               </a:rPr>
-              <a:t>주: LLM 호출비는 Claude API 가격표(2026.10, 1달러=1,400원) 기준, 재시도·서버·검수 별도 / 배달대행 기본료 보도 사례: 2024년 일부 업체 4,900~5,800원</a:t>
+              <a:t>주: LLM 호출비는 Claude API 가격표(2026.10, 1달러=1,400원) 기준, 재시도·서버·검수 별도 / 배달대행 요금은 견적으로 확인 (2024.10 일부 업체 5,400~5,800원 인상 예정 보도)</a:t>
             </a:r>
             <a:endParaRPr lang="en-US" sz="900" dirty="0"/>
           </a:p>
@@ -8336,7 +8336,7 @@
                 <a:solidFill>
                   <a:srgbClr val="1F2421"/>
                 </a:solidFill>
-                <a:hlinkClick r:id="rId9" invalidUrl="" action="" tgtFrame="" tooltip="https://www.munhwa.com/article/11458547" history="1" highlightClick="0" endSnd="0">
+                <a:hlinkClick r:id="rId9" invalidUrl="" action="" tgtFrame="" tooltip="https://biz.newdaily.co.kr/site/data/html/2024/10/07/2024100700114.amp.html" history="1" highlightClick="0" endSnd="0">
                   <a:extLst>
                     <a:ext uri="{A12FA001-AC4F-418D-AE19-62706E023703}">
                       <ahyp:hlinkClr xmlns:ahyp="http://schemas.microsoft.com/office/drawing/2018/hyperlinkcolor" val="tx"/>
@@ -8344,7 +8344,7 @@
                   </a:extLst>
                 </a:hlinkClick>
               </a:rPr>
-              <a:t>문화일보 · 뉴데일리, 배달대행 기본료 인상 보도 (2024.10)</a:t>
+              <a:t>뉴데일리, 배달대행 기본료 인상 예정 보도 (2024.10.07)</a:t>
             </a:r>
             <a:endParaRPr lang="en-US" sz="1050" dirty="0"/>
           </a:p>
@@ -10573,7 +10573,7 @@
                   <a:srgbClr val="1F2421"/>
                 </a:solidFill>
               </a:rPr>
-              <a:t>적은 입력으로 상품 등록 · 손질 서비스 홍보 · 예약 주문 통로</a:t>
+              <a:t>간단한 상품 등록과 손질·예약 주문</a:t>
             </a:r>
             <a:endParaRPr lang="en-US" sz="1150" dirty="0"/>
           </a:p>
@@ -16054,7 +16054,7 @@
                   <a:schemeClr val="tx1"/>
                 </a:solidFill>
               </a:rPr>
-              <a:t>중개 수수료를 기본 수익원으로 하고 판매자 유료 서비스·제휴 광고로 확대, 배달은 마진 없이 연결</a:t>
+              <a:t>중개 수수료를 기본 수익원으로 하고 판매자 유료 서비스·제휴 광고로 확대, 배달은 별도 이익 없이 연결</a:t>
             </a:r>
             <a:endParaRPr lang="en-US" sz="1300" dirty="0"/>
           </a:p>
@@ -16766,7 +16766,7 @@
                             <a:srgbClr val="1F2421"/>
                           </a:solidFill>
                         </a:rPr>
-                        <a:t>배달비 제외 · 일반·예약 공통 · 전통시장 점포 첫 6개월 0%</a:t>
+                        <a:t>배달비 제외 / 전통시장 첫 6개월 면제</a:t>
                       </a:r>
                       <a:endParaRPr lang="en-US" sz="1200" dirty="0"/>
                     </a:p>
@@ -16897,7 +16897,7 @@
                             <a:srgbClr val="1F2421"/>
                           </a:solidFill>
                         </a:rPr>
-                        <a:t>매출 제외(마진 없음) · 차액은 파일럿 예산 한도 내 부담</a:t>
+                        <a:t>매출 목표에서 제외 / 차액은 시험 예산으로 지원</a:t>
                       </a:r>
                       <a:endParaRPr lang="en-US" sz="1200" dirty="0"/>
                     </a:p>

</xml_diff>

<commit_message>
namul: v4.6 — Codex 5차 리뷰 반영
- 고사리 56톤: '중국산과 국내산을 섞은 고사리 56톤을 국내산으로 속여 급식용으로
  납품'으로 정정 (Q&A, 01, 07)
- 시장에 표시하는 금액: '보탰어요·돌아간 금액' → '○○상회에서 ○○원어치
  주문했어요 · 이 금액은 그 가게의 매출이 돼요 (상품·손질 금액, 배달비 제외)'.
  4번 띠 '시장 가게 주문 내역', 01 §2.6에 기부액·순이익·최종 입금액이 아님을 명시
- 가격 범위: '2026년 추석 서울 제수용품 조사의 채소·임산물류'로, '시장 시세로
  판다' → '가게가 등록한 가격과 손질·배달비를 나눠 보여 준다'
- 신뢰: 상품별 원산지·입고일 표시는 출시 계획임을 명시 (현재 시연 범위 구분)
- 01의 직매장 연계·동네 가게 문구 정리, 한 줄 정의를 중심 문장으로
- 탐스 비유는 발표자 요청이라 유지하되 대비로 바꿈 ('한 켤레가 기부되던 탐스처럼
  … 나물값은 그대로 시장 가게의 매출'), 표지 대본은 서비스 설명 → 의미 순서
- 4·5·6번 반복 설명 축소, 슬로건은 표지에만, 12번 부제 '레시피에서 우리 동네
  시장 장보기까지', 앱 외곽 AI 안내 문구 정정
- 대본 추정 8:49, AI 음성 초안 8:50

Co-Authored-By: Claude Opus 5.5 <noreply@anthropic.com>
Claude-Session: https://claude.ai/code/session_01WM2pJ2E8tXi8UPjx1jXtrm
</commit_message>
<xml_diff>
--- a/namul-platform/02_발표자료_나물로.pptx
+++ b/namul-platform/02_발표자료_나물로.pptx
@@ -120,43 +120,43 @@
   <p:extLst>
     <p:ext uri="{521415D9-36F7-43E2-AB2F-B90AF26B5E84}">
       <p14:sectionLst xmlns:p14="http://schemas.microsoft.com/office/powerpoint/2010/main">
-        <p14:section name="표지" id="{e9915168-beea-ab37-a906-073b344feaa2}">
+        <p14:section name="표지" id="{cec2bf3e-83d5-122a-085f-0c733ae9aa15}">
           <p14:sldIdLst>
             <p14:sldId id="256"/>
           </p14:sldIdLst>
         </p14:section>
-        <p14:section name="Problem" id="{bc565920-401d-5137-3939-d70340dec115}">
+        <p14:section name="Problem" id="{c01797ca-e800-5450-2467-a101cbd6c20f}">
           <p14:sldIdLst>
             <p14:sldId id="257"/>
             <p14:sldId id="258"/>
           </p14:sldIdLst>
         </p14:section>
-        <p14:section name="Solution" id="{196ce7ac-0bad-0d74-d057-d44206719c84}">
+        <p14:section name="Solution" id="{483600ee-4c4b-6acf-17ea-5602bccbc6bb}">
           <p14:sldIdLst>
             <p14:sldId id="259"/>
             <p14:sldId id="260"/>
             <p14:sldId id="261"/>
           </p14:sldIdLst>
         </p14:section>
-        <p14:section name="Business" id="{436031ff-c2e8-ccee-cc26-47eb3a203ede}">
+        <p14:section name="Business" id="{8a636e99-11e1-4e87-ef3c-717d605896ef}">
           <p14:sldIdLst>
             <p14:sldId id="262"/>
             <p14:sldId id="263"/>
             <p14:sldId id="264"/>
           </p14:sldIdLst>
         </p14:section>
-        <p14:section name="Vision" id="{7f4f1790-ee19-2053-066a-b861b5162b95}">
+        <p14:section name="Vision" id="{a979b934-47c1-17dd-7902-ba24749d1d3f}">
           <p14:sldIdLst>
             <p14:sldId id="265"/>
             <p14:sldId id="266"/>
           </p14:sldIdLst>
         </p14:section>
-        <p14:section name="마무리" id="{d3f3784f-dbb8-33ab-0cd1-9aeaab07794a}">
+        <p14:section name="마무리" id="{56e24466-fa04-6cc3-ff3f-af2f9847fb5e}">
           <p14:sldIdLst>
             <p14:sldId id="267"/>
           </p14:sldIdLst>
         </p14:section>
-        <p14:section name="부록" id="{17024943-ac61-841b-b3c4-1262bb6cc102}">
+        <p14:section name="부록" id="{00048f54-128f-7c75-2fc2-7511c65d0e84}">
           <p14:sldIdLst>
             <p14:sldId id="268"/>
             <p14:sldId id="269"/>
@@ -859,7 +859,7 @@
           <a:p>
             <a:r>
               <a:rPr lang="en-US" dirty="0"/>
-              <a:t>[0:00–0:42] 안녕하세요. 오늘 발표할 창업 아이템은 나물로입니다. 나물로는 레시피를 고르면 필요한 나물을 가까운 전통시장 가게에 온라인으로 주문하고, 시장에서 받거나 저녁에 배달받는 O2O 서비스입니다. 나물을 더 쉽게 살 수 있게 하고, 레시피와 장보기를 연결하며, 메뉴 추천과 상품 등록에는 AI를 씁니다. 무엇보다 탐스 신발을 산 사람들이 신발과 함께 기부의 의미를 샀던 것처럼, 나물을 사면서 지역 상권을 돕는다는 걸 느낄 수 있게 하려고 합니다. 문제, 해결 방안, 사업성, 향후 계획 순서로 말씀드리겠습니다.</a:t>
+              <a:t>[0:00–0:40] 안녕하세요. 오늘 발표할 창업 아이템은 나물로입니다. 나물로는 레시피에서 고른 나물을 가까운 전통시장 가게에 온라인으로 주문하는 O2O 서비스입니다. AI가 메뉴 추천과 상품 등록을 돕고, 고객은 손질한 나물을 시장에서 찾아가거나 저녁에 배달받습니다. 신발 한 켤레를 사면 한 켤레가 기부되던 탐스처럼 장보기에도 의미를 담고 싶었습니다. 나물로에서 낸 나물값은 그대로 우리 동네 시장 가게의 매출이 됩니다. 문제, 해결 방안, 사업성, 향후 계획 순서로 말씀드리겠습니다.</a:t>
             </a:r>
             <a:endParaRPr lang="en-US" dirty="0"/>
           </a:p>
@@ -947,7 +947,7 @@
           <a:p>
             <a:r>
               <a:rPr lang="en-US" dirty="0"/>
-              <a:t>[7:08–7:55] 사업화는 세 단계로 진행합니다. 1단계는 올겨울, 주거 단지 근처 전통시장 한 곳의 점포 두세 곳과 함께하는 3개월 파일럿입니다. 자기자본 300만 원으로 시작합니다. 여기서 유료 주문 100건을 목표로, 30일 재구매율, 손질 옵션 선택률, 배달 선택률과 배달 한 건당 비용, 주문당 운영 시간을 측정하겠습니다. 결과가 기대에 못 미치면 타깃 고객이나 가격을 바꿔 다시 검증하겠습니다. 2단계는 예비창업패키지 같은 정부 지원사업으로 웹앱을 정식 출시하고 명절 예약을 열며 입점 매장을 30곳으로 늘리는 것이고, 3단계는 시드 투자를 받아 수도권으로 확장하는 것입니다.</a:t>
+              <a:t>[6:56–7:43] 사업화는 세 단계로 진행합니다. 1단계는 올겨울, 주거 단지 근처 전통시장 한 곳의 점포 두세 곳과 함께하는 3개월 파일럿입니다. 자기자본 300만 원으로 시작합니다. 여기서 유료 주문 100건을 목표로, 30일 재구매율, 손질 옵션 선택률, 배달 선택률과 배달 한 건당 비용, 주문당 운영 시간을 측정하겠습니다. 결과가 기대에 못 미치면 타깃 고객이나 가격을 바꿔 다시 검증하겠습니다. 2단계는 예비창업패키지 같은 정부 지원사업으로 웹앱을 정식 출시하고 명절 예약을 열며 입점 매장을 30곳으로 늘리는 것이고, 3단계는 시드 투자를 받아 수도권으로 확장하는 것입니다.</a:t>
             </a:r>
             <a:endParaRPr lang="en-US" dirty="0"/>
           </a:p>
@@ -1035,7 +1035,7 @@
           <a:p>
             <a:r>
               <a:rPr lang="en-US" dirty="0"/>
-              <a:t>[7:55–8:40] 3년 차 목표는 거래액 54억 원, 매출 약 2.6억 원입니다. 매출 목표는 주문 수수료와 판매자 유료 서비스로 계산했고, 지자체 사업이나 제휴 매출은 계약을 확보한 뒤 반영하겠습니다. 보수적으로 매장당 월 약 77건으로 잡으면 매출은 약 2.1억 원이고, 숫자는 모두 가정이라 파일럿이 끝나면 실제 데이터로 다시 계산하겠습니다. 확장은 첫 시장에서 재구매와 주문당 운영비를 확인한 뒤, 인접 시장과 제철 농산물 전체로 넓혀 가겠습니다. 이를 통해 전통시장의 매출을 늘리고, 아이들이 채소 반찬을 더 쉽게 먹도록 돕는 것이 목표입니다.</a:t>
+              <a:t>[7:43–8:28] 3년 차 목표는 거래액 54억 원, 매출 약 2.6억 원입니다. 매출 목표는 주문 수수료와 판매자 유료 서비스로 계산했고, 지자체 사업이나 제휴 매출은 계약을 확보한 뒤 반영하겠습니다. 보수적으로 매장당 월 약 77건으로 잡으면 매출은 약 2.1억 원이고, 숫자는 모두 가정이라 파일럿이 끝나면 실제 데이터로 다시 계산하겠습니다. 확장은 첫 시장에서 재구매와 주문당 운영비를 확인한 뒤, 인접 시장과 제철 농산물 전체로 넓혀 가겠습니다. 이를 통해 전통시장의 매출을 늘리고, 아이들이 채소 반찬을 더 쉽게 먹도록 돕는 것이 목표입니다.</a:t>
             </a:r>
             <a:endParaRPr lang="en-US" dirty="0"/>
           </a:p>
@@ -1123,7 +1123,7 @@
           <a:p>
             <a:r>
               <a:rPr lang="en-US" dirty="0"/>
-              <a:t>[8:40–9:02] 정리하겠습니다. 나물로는 레시피와 AI로 나물을 쉽게 고르고, 전통시장에서 사는 장보기가 지역 상권을 돕는 일이 되도록 만드는 서비스입니다. 먼저 시장 한 곳에서 사람들이 실제로 주문하고 다시 찾아오는지 확인해 보겠습니다. 들어 주셔서 감사합니다.</a:t>
+              <a:t>[8:28–8:49] 정리하겠습니다. 나물로는 레시피와 AI로 장보기를 쉽게 하고, 그 장보기가 우리 동네 시장 가게의 매출이 되도록 돕는 서비스입니다. 먼저 시장 한 곳에서 사람들이 실제로 주문하고 다시 찾아오는지 확인해 보겠습니다. 들어 주셔서 감사합니다.</a:t>
             </a:r>
             <a:endParaRPr lang="en-US" dirty="0"/>
           </a:p>
@@ -1387,7 +1387,7 @@
           <a:p>
             <a:r>
               <a:rPr lang="en-US" dirty="0"/>
-              <a:t>[0:42–1:32] 먼저 고객 쪽 문제입니다. 처음에는 전통시장 근처에 살면서 아이를 키우는 맞벌이 가정을 대상으로 생각했습니다. 18세 미만 자녀를 둔 부부 가구 가운데 맞벌이 비율은 작년에 60.4%로, 처음 60%를 넘었습니다. 장을 보고 요리할 시간이 부족하고, 아이가 채소 반찬을 잘 먹지 않아 메뉴 고르기도 어렵습니다. 나물은 다듬고 데치는 손질이 번거롭고, 시장 나물이 싸고 믿을 만해도 퇴근 후에는 시장에 들르기 어렵습니다. 대구 지역 유아 86명을 조사한 연구에서도 반찬류를 꺼리는 경향이 나타났습니다. 그래서 무엇을 어디서 사서 어떻게 해 먹을지를 한 번에 알려 주는 서비스가 필요하다고 봤습니다.</a:t>
+              <a:t>[0:40–1:30] 먼저 고객 쪽 문제입니다. 처음에는 전통시장 근처에 살면서 아이를 키우는 맞벌이 가정을 대상으로 생각했습니다. 18세 미만 자녀를 둔 부부 가구 가운데 맞벌이 비율은 작년에 60.4%로, 처음 60%를 넘었습니다. 장을 보고 요리할 시간이 부족하고, 아이가 채소 반찬을 잘 먹지 않아 메뉴 고르기도 어렵습니다. 나물은 다듬고 데치는 손질이 번거롭고, 시장 나물을 사려 해도 퇴근 후에는 시장에 들르기 어렵습니다. 대구 지역 유아 86명을 조사한 연구에서도 반찬류를 꺼리는 경향이 나타났습니다. 그래서 무엇을 어디서 사서 어떻게 해 먹을지를 한 번에 알려 주는 서비스가 필요하다고 봤습니다.</a:t>
             </a:r>
             <a:endParaRPr lang="en-US" dirty="0"/>
           </a:p>
@@ -1475,7 +1475,7 @@
           <a:p>
             <a:r>
               <a:rPr lang="en-US" dirty="0"/>
-              <a:t>[1:32–2:25] 다음은 판매자 쪽입니다. 전국 전통시장은 약 1,400곳, 연매출은 28.7조 원 규모입니다. 배민 전통시장 장보기에 입점한 점포의 매출이 1년 사이 196% 늘었다는 보도를 보면, 시장 상품을 온라인으로 사려는 수요는 있다고 판단했습니다. 다만 상인이 상품을 올리고 주문까지 직접 관리하려면 일이 꽤 늘어날 것으로 봤습니다. 손질해서 팔면 값을 더 받을 수 있는데도 이를 알릴 방법이 마땅치 않고, 제철에는 물량이 몰려 재고 부담도 클 것으로 예상합니다. 그래서 판매자에게는 상품을 쉽게 올리고 손질 주문을 미리 받을 수 있는 통로가 필요하다고 봤습니다. 이 부분은 아직 가설이라서, 시장 상인 인터뷰로 실제 부담을 확인하려고 합니다.</a:t>
+              <a:t>[1:30–2:23] 다음은 판매자 쪽입니다. 전국 전통시장은 약 1,400곳, 연매출은 28.7조 원 규모입니다. 배민 전통시장 장보기에 입점한 점포의 매출이 1년 사이 196% 늘었다는 보도를 보면, 시장 상품을 온라인으로 사려는 수요는 있다고 판단했습니다. 다만 상인이 상품을 올리고 주문까지 직접 관리하려면 일이 꽤 늘어날 것으로 봤습니다. 손질해서 팔면 값을 더 받을 수 있는데도 이를 알릴 방법이 마땅치 않고, 제철에는 물량이 몰려 재고 부담도 클 것으로 예상합니다. 그래서 판매자에게는 상품을 쉽게 올리고 손질 주문을 미리 받을 수 있는 통로가 필요하다고 봤습니다. 이 부분은 아직 가설이라서, 시장 상인 인터뷰로 실제 부담을 확인하려고 합니다.</a:t>
             </a:r>
             <a:endParaRPr lang="en-US" dirty="0"/>
           </a:p>
@@ -1563,7 +1563,7 @@
           <a:p>
             <a:r>
               <a:rPr lang="en-US" dirty="0"/>
-              <a:t>[2:25–3:25] 그래서 나물로는 세 단계로 서비스를 제공합니다. 첫째, 제철 나물 정보와 손질법, 레시피를 보여 주고, 아이가 잘 먹는 메뉴를 따로 추천합니다. 둘째, 레시피 재료 가운데 집에 없는 것만 골라 장바구니에 담습니다. 셋째, 가까운 전통시장의 나물 가게 가운데 한 곳을 고르고, 시장에서 찾아갈지 저녁에 배달받을지 정합니다. 배달을 고르면 가게에서 상품을 준비하고, 나물로가 배달대행에 배달을 요청합니다. 손질이나 데침을 원하면 가게에서 추가 요금을 받고 처리해 주고, 설 차례 나물처럼 주문이 몰리는 날은 미리 예약을 받습니다. 주문을 마치면 이번 주문으로 어느 시장 가게에 얼마가 돌아갔는지 보여 줘서, 장보기가 지역 상권을 돕는다는 걸 느낄 수 있게 합니다. 이렇게 고객의 준비 시간과 시장 가게의 판매 부담을 함께 줄이려고 합니다.</a:t>
+              <a:t>[2:23–3:10] 그래서 나물로는 세 단계로 서비스를 제공합니다. 첫째, 제철 나물 정보와 손질법, 레시피를 보여 주고, 아이가 잘 먹는 메뉴를 따로 추천합니다. 둘째, 레시피 재료 가운데 집에 없는 것만 골라 장바구니에 담습니다. 셋째, 가까운 전통시장의 나물 가게 가운데 한 곳을 고르고, 시장에서 찾아갈지 저녁에 배달받을지 정합니다. 손질이나 데침을 원하면 가게에서 추가 요금을 받고 처리해 줍니다. 주문을 마치면 어느 시장 가게에서 얼마를 샀는지 보여 주고, 그 금액이 그 가게의 매출이 된다는 걸 알 수 있게 합니다. 이렇게 고객의 준비 시간과 시장 가게의 판매 부담을 함께 줄이려고 합니다.</a:t>
             </a:r>
             <a:endParaRPr lang="en-US" dirty="0"/>
           </a:p>
@@ -1651,7 +1651,7 @@
           <a:p>
             <a:r>
               <a:rPr lang="en-US" dirty="0"/>
-              <a:t>[3:25–4:18] AI는 세 가지 업무에 적용하려고 합니다. 첫째는 고객용 레시피 추천입니다. 아이 나이나 집에 있는 재료를 입력하면, 근처 시장 가게 재고로 만들 수 있는 반찬을 추천합니다. 둘째는 판매자용 상품 등록입니다. 사장님이 평소처럼 참나물 스무 단, 한 단 3,500원이라고 메시지를 보내면, AI가 품목과 수량, 가격으로 정리하고, 사장님이 확인을 눌러야 앱에 올라갑니다. 셋째는 발주량 추천과 마감 할인인데, 이 기능은 주문 데이터가 쌓인 뒤에 도입할 계획입니다. 앞의 두 기능은 시연 화면까지 만들어 두었고, 화면의 응답과 매장, 가격은 예시 데이터입니다. 또 안전을 위해 AI가 야생에서 캔 식물의 식용 여부는 판단하지 않도록 했습니다.</a:t>
+              <a:t>[3:10–4:01] AI는 세 가지 업무에 적용하려고 합니다. 첫째는 고객용 레시피 추천입니다. 아이 나이나 집에 있는 재료를 입력하면, 근처 시장 가게 재고로 만들 수 있는 반찬을 추천합니다. 둘째는 판매자용 상품 등록입니다. 사장님이 평소처럼 참나물 스무 단, 한 단 3,500원이라고 메시지를 보내면, AI가 품목과 수량, 가격으로 정리하고, 사장님이 확인을 눌러야 앱에 올라갑니다. 발주량 추천과 마감 할인은 판매 데이터가 쌓인 뒤에 도입하겠습니다. 앞의 두 기능은 시연 화면까지 만들어 두었고, 화면의 응답과 매장, 가격은 예시 데이터입니다. 또 안전을 위해 AI가 야생에서 캔 식물의 식용 여부는 판단하지 않도록 했습니다.</a:t>
             </a:r>
             <a:endParaRPr lang="en-US" dirty="0"/>
           </a:p>
@@ -1739,7 +1739,7 @@
           <a:p>
             <a:r>
               <a:rPr lang="en-US" dirty="0"/>
-              <a:t>[4:18–4:58] 웹 프로토타입으로 사용 흐름을 보여 드리겠습니다. 맞벌이 부모가 다섯 살 아이와 먹을 순한 반찬을 물으면, 추천 메뉴 세 가지가 나옵니다. 참나물 레시피를 보고 재료를 담은 뒤, 600미터 떨어진 시장 가게에서 손질 옵션을 고릅니다. 받는 방법은 가게 픽업과 저녁 배달 중에 고를 수 있는데, 여기서는 저녁 6시 픽업을 골랐습니다. 판매자 화면에서는 들어온 주문을 확인하고 접수합니다. 시연 속 AI 응답과 주문 데이터는 예시이고, 실제 결제와 배달 연동은 파일럿에서 검증하겠습니다.</a:t>
+              <a:t>[4:01–4:39] 웹 프로토타입으로 사용 흐름을 보여 드리겠습니다. 맞벌이 부모가 다섯 살 아이와 먹을 순한 반찬을 물으면, 추천 메뉴 세 가지가 나옵니다. 참나물 레시피를 보고 재료를 담은 뒤, 새벽시장 가게에서 손질 옵션을 고르고 저녁 6시 픽업으로 예약합니다. 완료 화면에서는 주문한 시장 가게와 주문금액을 확인하고, 판매자 화면에서는 들어온 주문을 접수합니다. 시연 속 AI 응답과 주문 데이터는 예시이고, 실제 결제와 배달 연동은 파일럿에서 검증하겠습니다.</a:t>
             </a:r>
             <a:endParaRPr lang="en-US" dirty="0"/>
           </a:p>
@@ -1827,7 +1827,7 @@
           <a:p>
             <a:r>
               <a:rPr lang="en-US" dirty="0"/>
-              <a:t>[4:58–5:36] 다음은 시장 규모입니다. 전통시장 전체 매출 28.7조 원에서 수도권 비중 40%와 채소, 나물류 비중 15%를 가정해, 1차 목표 시장을 약 1.7조 원으로 잡았습니다. 수도권과 품목 비중은 공개 통계로 보완하고, 파일럿에서는 참여 점포의 나물 매출과 주문 가능성을 확인하겠습니다. 3년 차 목표 거래액은 입점 매장 300곳이 일반 주문과 명절 예약을 합쳐 한 달에 100건씩, 평균 1만 5천 원 주문을 받는다고 가정해 54억 원으로 정했습니다.</a:t>
+              <a:t>[4:39–5:17] 다음은 시장 규모입니다. 전통시장 전체 매출 28.7조 원에서 수도권 비중 40%와 채소, 나물류 비중 15%를 가정해, 1차 목표 시장을 약 1.7조 원으로 잡았습니다. 수도권과 품목 비중은 공개 통계로 보완하고, 파일럿에서는 참여 점포의 나물 매출과 주문 가능성을 확인하겠습니다. 3년 차 목표 거래액은 입점 매장 300곳이 일반 주문과 명절 예약을 합쳐 한 달에 100건씩, 평균 1만 5천 원 주문을 받는다고 가정해 54억 원으로 정했습니다.</a:t>
             </a:r>
             <a:endParaRPr lang="en-US" dirty="0"/>
           </a:p>
@@ -1915,7 +1915,7 @@
           <a:p>
             <a:r>
               <a:rPr lang="en-US" dirty="0"/>
-              <a:t>[5:36–6:23] 경쟁 서비스를 보면, 쿠팡과 컬리는 전국 배송, 레시피 앱과 유튜브는 콘텐츠, 배민과 네이버는 동네 가게 주문에 강합니다. 나물로는 레시피로 고른 재료를 전통시장 가게에서 바로 사도록 연결하는 데 집중했습니다. 올해 추석 조사에서 채소와 나물류는 전통시장이 대형마트보다 26% 쌌는데, 나물로는 시장 가격으로 팔고 주문마다 시장에 돌아간 금액을 보여 줍니다. 손질과 데침 옵션은 판매자에게는 추가 매출이 되고, 고객에게는 조리 시간을 줄여 줍니다. 큰 플랫폼과 정면으로 경쟁하기보다, 전통시장 상인과 함께 크는 나물 전문 채널이 되는 것이 목표입니다.</a:t>
+              <a:t>[5:17–6:11] 경쟁 서비스를 보면, 쿠팡과 컬리는 전국 배송, 레시피 앱과 유튜브는 콘텐츠, 배민과 네이버는 동네 가게 주문에 강합니다. 나물로는 레시피로 고른 재료를 전통시장 가게에서 바로 사도록 연결하는 데 집중했습니다. 2026년 추석 서울 제수용품 조사에서 채소·임산물류는 전통시장이 대형마트보다 26% 저렴했습니다. 나물로에서는 가게가 등록한 가격과 손질·배달비를 나눠 보여 주고, 주문마다 어느 시장 가게의 매출이 됐는지 표시합니다. 손질과 데침 옵션은 판매자에게는 추가 매출이 되고, 고객에게는 조리 시간을 줄여 줍니다. 큰 플랫폼과 정면으로 경쟁하기보다, 전통시장 가게가 새 주문을 받을 수 있는 나물 전문 채널이 되는 것이 목표입니다.</a:t>
             </a:r>
             <a:endParaRPr lang="en-US" dirty="0"/>
           </a:p>
@@ -2003,7 +2003,7 @@
           <a:p>
             <a:r>
               <a:rPr lang="en-US" dirty="0"/>
-              <a:t>[6:23–7:08] 수익 모델은 세 가지입니다. 요금은 모두 예정안이고, 파일럿에서 검증할 계획입니다. 기본은 상품과 손질 금액의 4%를 받는 중개 수수료이고, 판매자가 선택하는 월 2만 9천 원의 유료 서비스와 제휴 광고를 더합니다. 배달비에는 별도 이익을 붙이지 않을 계획이라, 매출 목표에서 제외했습니다. 배달비 3,500원은 시험 요금이고, 보도된 일부 배달대행 기본료는 이보다 높아서, 차액은 파일럿 예산 안에서 한도를 정해 부담하겠습니다. 판매자 부담은 월 100건 매장 기준 거래액의 약 6%이고, 전통시장 점포는 첫 6개월 수수료를 받지 않겠습니다.</a:t>
+              <a:t>[6:11–6:56] 수익 모델은 세 가지입니다. 요금은 모두 예정안이고, 파일럿에서 검증할 계획입니다. 기본은 상품과 손질 금액의 4%를 받는 중개 수수료이고, 판매자가 선택하는 월 2만 9천 원의 유료 서비스와 제휴 광고를 더합니다. 배달비에는 별도 이익을 붙이지 않을 계획이라, 매출 목표에서 제외했습니다. 배달비 3,500원은 시험 요금이고, 보도된 일부 배달대행 기본료는 이보다 높아서, 차액은 파일럿 예산 안에서 한도를 정해 부담하겠습니다. 판매자 부담은 월 100건 매장 기준 거래액의 약 6%이고, 전통시장 점포는 첫 6개월 수수료를 받지 않겠습니다.</a:t>
             </a:r>
             <a:endParaRPr lang="en-US" dirty="0"/>
           </a:p>
@@ -3298,7 +3298,7 @@
                   <a:srgbClr val="C7D6CC"/>
                 </a:solidFill>
               </a:rPr>
-              <a:t>나물 한 봉지로 지역 상권을 돕는 가치소비 장보기</a:t>
+              <a:t>나물 한 봉지로 지역 상권을 돕는 장보기</a:t>
             </a:r>
             <a:endParaRPr lang="en-US" sz="1300" dirty="0"/>
           </a:p>
@@ -5821,7 +5821,7 @@
                   <a:srgbClr val="DCE7E0"/>
                 </a:solidFill>
               </a:rPr>
-              <a:t>나물 한 봉지로 지역 상권을 돕는 장보기</a:t>
+              <a:t>레시피에서 우리 동네 시장 장보기까지</a:t>
             </a:r>
             <a:endParaRPr lang="en-US" sz="1500" dirty="0"/>
           </a:p>
@@ -9492,7 +9492,7 @@
                   <a:srgbClr val="4A524D"/>
                 </a:solidFill>
               </a:rPr>
-              <a:t>시장 나물이 싸고 믿을 만해도</a:t>
+              <a:t>시장 나물을 사고 싶어도</a:t>
             </a:r>
             <a:endParaRPr lang="en-US" sz="1200" dirty="0"/>
           </a:p>
@@ -11417,7 +11417,7 @@
                   <a:srgbClr val="1F2421"/>
                 </a:solidFill>
               </a:rPr>
-              <a:t>시장 픽업(무료)·저녁 배달 선택, 명절 나물은 예약</a:t>
+              <a:t>시장 픽업(무료) 또는 저녁 배달 선택</a:t>
             </a:r>
             <a:endParaRPr lang="en-US" sz="1200" dirty="0"/>
           </a:p>
@@ -11478,7 +11478,7 @@
                   <a:srgbClr val="1E4D3A"/>
                 </a:solidFill>
               </a:rPr>
-              <a:t>+ 시장 기여 표시   </a:t>
+              <a:t>+ 시장 가게 주문 내역   </a:t>
             </a:r>
             <a:pPr indent="0" marL="0">
               <a:buNone/>
@@ -11489,7 +11489,7 @@
                   <a:srgbClr val="1F2421"/>
                 </a:solidFill>
               </a:rPr>
-              <a:t>주문마다 그 시장 가게에 돌아간 금액을 보여 줌</a:t>
+              <a:t>어느 시장 가게에서 얼마를 샀는지 표시</a:t>
             </a:r>
             <a:endParaRPr lang="en-US" sz="1200" dirty="0"/>
           </a:p>
@@ -14855,7 +14855,7 @@
                   <a:schemeClr val="tx1"/>
                 </a:solidFill>
               </a:rPr>
-              <a:t>레시피로 고른 재료를 전통시장 가게에서 싸고 믿을 수 있게 사고, 그 구매가 지역 상권을 돕게 함</a:t>
+              <a:t>레시피에서 고른 나물을 전통시장 가게에 주문하고, 가게별 주문금액을 보여 줌</a:t>
             </a:r>
             <a:endParaRPr lang="en-US" sz="1300" dirty="0"/>
           </a:p>
@@ -15885,7 +15885,7 @@
                   <a:srgbClr val="4A524D"/>
                 </a:solidFill>
               </a:rPr>
-              <a:t>시장 시세로 팔고, 시장에 돌아간 금액 표시</a:t>
+              <a:t>가게가 등록한 가격과 주문 내역을 확인</a:t>
             </a:r>
             <a:endParaRPr lang="en-US" sz="1150" dirty="0"/>
           </a:p>
@@ -16079,7 +16079,7 @@
                   <a:srgbClr val="1E4D3A"/>
                 </a:solidFill>
               </a:rPr>
-              <a:t>목표: 전통시장 상인과 함께 크는 나물 전문 채널</a:t>
+              <a:t>목표: 전통시장 가게의 나물 전문 주문 채널</a:t>
             </a:r>
             <a:endParaRPr lang="en-US" sz="1100" dirty="0"/>
           </a:p>

</xml_diff>